<commit_message>
style: switch all presentation outputs to white/light-blue theme
- Background: #F0F6FF (very light blue) replacing dark #0F1117
- Cards: white (#FFFFFF) with light blue-gray alternates (#E5EEFC)
- Primary text: near-black (#0F172A) for strong contrast
- Status tints: light GDIM/YDIM/RDIM/BDIM replacing dark dim colors
- Accent, Green, Yellow, Red adjusted for readability on light backgrounds
- Updated: build_pptx.py, build_pdf.py, build_thumbnails.py, index.html
- Regenerated: RHP_Executive_Status.pptx, .pdf, all 8 slide PNGs

Co-authored-by: amantrala30 <amantrala30@users.noreply.github.com>
</commit_message>
<xml_diff>
--- a/dashboard/RHP_Executive_Status.pptx
+++ b/dashboard/RHP_Executive_Status.pptx
@@ -3091,7 +3091,7 @@
     <p:bg>
       <p:bgPr>
         <a:solidFill>
-          <a:srgbClr val="0F1117"/>
+          <a:srgbClr val="F0F6FF"/>
         </a:solidFill>
         <a:effectLst/>
       </p:bgPr>
@@ -3118,7 +3118,7 @@
             <a:avLst/>
           </a:prstGeom>
           <a:solidFill>
-            <a:srgbClr val="4F8EF7"/>
+            <a:srgbClr val="2563EB"/>
           </a:solidFill>
           <a:ln>
             <a:noFill/>
@@ -3161,7 +3161,7 @@
             <a:avLst/>
           </a:prstGeom>
           <a:solidFill>
-            <a:srgbClr val="1A1D27"/>
+            <a:srgbClr val="FFFFFF"/>
           </a:solidFill>
           <a:ln>
             <a:noFill/>
@@ -3215,7 +3215,7 @@
             <a:r>
               <a:rPr sz="3200" b="1" i="0">
                 <a:solidFill>
-                  <a:srgbClr val="FFFFFF"/>
+                  <a:srgbClr val="0F172A"/>
                 </a:solidFill>
               </a:rPr>
               <a:t>Radiological Health Program</a:t>
@@ -3249,7 +3249,7 @@
             <a:r>
               <a:rPr sz="2600" b="0" i="0">
                 <a:solidFill>
-                  <a:srgbClr val="4F8EF7"/>
+                  <a:srgbClr val="2563EB"/>
                 </a:solidFill>
               </a:rPr>
               <a:t>Modernization Initiative</a:t>
@@ -3283,7 +3283,7 @@
             <a:r>
               <a:rPr sz="1300" b="0" i="0">
                 <a:solidFill>
-                  <a:srgbClr val="8F96B3"/>
+                  <a:srgbClr val="4A5A82"/>
                 </a:solidFill>
               </a:rPr>
               <a:t>Executive Status Report  ·  FY26  ·  June 12, 2026</a:t>
@@ -3306,7 +3306,7 @@
             <a:avLst/>
           </a:prstGeom>
           <a:solidFill>
-            <a:srgbClr val="784B05"/>
+            <a:srgbClr val="FEF3C7"/>
           </a:solidFill>
           <a:ln>
             <a:noFill/>
@@ -3360,7 +3360,7 @@
             <a:r>
               <a:rPr sz="1000" b="1" i="0">
                 <a:solidFill>
-                  <a:srgbClr val="F59E0B"/>
+                  <a:srgbClr val="D97706"/>
                 </a:solidFill>
               </a:rPr>
               <a:t>⬤  Overall Status: YELLOW</a:t>
@@ -3384,7 +3384,7 @@
           </a:prstGeom>
           <a:ln w="6350">
             <a:solidFill>
-              <a:srgbClr val="2E3350"/>
+              <a:srgbClr val="C4D2EB"/>
             </a:solidFill>
           </a:ln>
         </p:spPr>
@@ -3429,7 +3429,7 @@
             <a:r>
               <a:rPr sz="900" b="0" i="0">
                 <a:solidFill>
-                  <a:srgbClr val="8F96B3"/>
+                  <a:srgbClr val="4A5A82"/>
                 </a:solidFill>
               </a:rPr>
               <a:t>Maryland Department of the Environment (MDE)  ·  PCA: 79103  ·  Fund: Radiation Control Fund</a:t>
@@ -3463,7 +3463,7 @@
             <a:r>
               <a:rPr sz="900" b="0" i="0">
                 <a:solidFill>
-                  <a:srgbClr val="8F96B3"/>
+                  <a:srgbClr val="4A5A82"/>
                 </a:solidFill>
               </a:rPr>
               <a:t>Prepared for Executive Review  ·  July 10, 2026</a:t>
@@ -3497,7 +3497,7 @@
             <a:r>
               <a:rPr sz="12000" b="0" i="0">
                 <a:solidFill>
-                  <a:srgbClr val="1A1F35"/>
+                  <a:srgbClr val="C0D4F0"/>
                 </a:solidFill>
               </a:rPr>
               <a:t>☢</a:t>
@@ -3519,7 +3519,7 @@
     <p:bg>
       <p:bgPr>
         <a:solidFill>
-          <a:srgbClr val="0F1117"/>
+          <a:srgbClr val="F0F6FF"/>
         </a:solidFill>
         <a:effectLst/>
       </p:bgPr>
@@ -3546,7 +3546,7 @@
             <a:avLst/>
           </a:prstGeom>
           <a:solidFill>
-            <a:srgbClr val="1A1D27"/>
+            <a:srgbClr val="FFFFFF"/>
           </a:solidFill>
           <a:ln>
             <a:noFill/>
@@ -3600,7 +3600,7 @@
             <a:r>
               <a:rPr sz="1600" b="1" i="0">
                 <a:solidFill>
-                  <a:srgbClr val="FFFFFF"/>
+                  <a:srgbClr val="0F172A"/>
                 </a:solidFill>
               </a:rPr>
               <a:t>Project Overview</a:t>
@@ -3623,7 +3623,7 @@
             <a:avLst/>
           </a:prstGeom>
           <a:solidFill>
-            <a:srgbClr val="784B05"/>
+            <a:srgbClr val="FEF3C7"/>
           </a:solidFill>
           <a:ln>
             <a:noFill/>
@@ -3677,7 +3677,7 @@
             <a:r>
               <a:rPr sz="900" b="1" i="0">
                 <a:solidFill>
-                  <a:srgbClr val="F59E0B"/>
+                  <a:srgbClr val="D97706"/>
                 </a:solidFill>
               </a:rPr>
               <a:t>Overall: YELLOW</a:t>
@@ -3700,11 +3700,11 @@
             <a:avLst/>
           </a:prstGeom>
           <a:solidFill>
-            <a:srgbClr val="1A1D27"/>
+            <a:srgbClr val="FFFFFF"/>
           </a:solidFill>
           <a:ln w="9525">
             <a:solidFill>
-              <a:srgbClr val="2E3350"/>
+              <a:srgbClr val="C4D2EB"/>
             </a:solidFill>
           </a:ln>
         </p:spPr>
@@ -3756,7 +3756,7 @@
             <a:r>
               <a:rPr sz="700" b="1" i="0">
                 <a:solidFill>
-                  <a:srgbClr val="8F96B3"/>
+                  <a:srgbClr val="4A5A82"/>
                 </a:solidFill>
               </a:rPr>
               <a:t>INITIATIVE</a:t>
@@ -3790,7 +3790,7 @@
             <a:r>
               <a:rPr sz="1050" b="0" i="0">
                 <a:solidFill>
-                  <a:srgbClr val="FFFFFF"/>
+                  <a:srgbClr val="0F172A"/>
                 </a:solidFill>
               </a:rPr>
               <a:t>The Radiological Health Program (RHP) is launching a strategic modernization initiative to transition its permitting and licensing application pipeline from legacy, manual workflows to a centralized online portal and electronic payment module.</a:t>
@@ -3824,7 +3824,7 @@
             <a:r>
               <a:rPr sz="700" b="1" i="0">
                 <a:solidFill>
-                  <a:srgbClr val="8F96B3"/>
+                  <a:srgbClr val="4A5A82"/>
                 </a:solidFill>
               </a:rPr>
               <a:t>HEALTH STATUS INDICATORS</a:t>
@@ -3847,11 +3847,11 @@
             <a:avLst/>
           </a:prstGeom>
           <a:solidFill>
-            <a:srgbClr val="22263A"/>
+            <a:srgbClr val="E5EEFC"/>
           </a:solidFill>
           <a:ln w="9525">
             <a:solidFill>
-              <a:srgbClr val="2E3350"/>
+              <a:srgbClr val="C4D2EB"/>
             </a:solidFill>
           </a:ln>
         </p:spPr>
@@ -3892,7 +3892,7 @@
             <a:avLst/>
           </a:prstGeom>
           <a:solidFill>
-            <a:srgbClr val="165B35"/>
+            <a:srgbClr val="DCFCE7"/>
           </a:solidFill>
           <a:ln>
             <a:noFill/>
@@ -3946,7 +3946,7 @@
             <a:r>
               <a:rPr sz="1000" b="1" i="0">
                 <a:solidFill>
-                  <a:srgbClr val="22C55E"/>
+                  <a:srgbClr val="16803D"/>
                 </a:solidFill>
               </a:rPr>
               <a:t>G</a:t>
@@ -3980,7 +3980,7 @@
             <a:r>
               <a:rPr sz="900" b="1" i="0">
                 <a:solidFill>
-                  <a:srgbClr val="FFFFFF"/>
+                  <a:srgbClr val="0F172A"/>
                 </a:solidFill>
               </a:rPr>
               <a:t>Scope</a:t>
@@ -4003,11 +4003,11 @@
             <a:avLst/>
           </a:prstGeom>
           <a:solidFill>
-            <a:srgbClr val="22263A"/>
+            <a:srgbClr val="E5EEFC"/>
           </a:solidFill>
           <a:ln w="9525">
             <a:solidFill>
-              <a:srgbClr val="2E3350"/>
+              <a:srgbClr val="C4D2EB"/>
             </a:solidFill>
           </a:ln>
         </p:spPr>
@@ -4048,7 +4048,7 @@
             <a:avLst/>
           </a:prstGeom>
           <a:solidFill>
-            <a:srgbClr val="165B35"/>
+            <a:srgbClr val="DCFCE7"/>
           </a:solidFill>
           <a:ln>
             <a:noFill/>
@@ -4102,7 +4102,7 @@
             <a:r>
               <a:rPr sz="1000" b="1" i="0">
                 <a:solidFill>
-                  <a:srgbClr val="22C55E"/>
+                  <a:srgbClr val="16803D"/>
                 </a:solidFill>
               </a:rPr>
               <a:t>G</a:t>
@@ -4136,7 +4136,7 @@
             <a:r>
               <a:rPr sz="900" b="1" i="0">
                 <a:solidFill>
-                  <a:srgbClr val="FFFFFF"/>
+                  <a:srgbClr val="0F172A"/>
                 </a:solidFill>
               </a:rPr>
               <a:t>Schedule</a:t>
@@ -4159,11 +4159,11 @@
             <a:avLst/>
           </a:prstGeom>
           <a:solidFill>
-            <a:srgbClr val="22263A"/>
+            <a:srgbClr val="E5EEFC"/>
           </a:solidFill>
           <a:ln w="9525">
             <a:solidFill>
-              <a:srgbClr val="2E3350"/>
+              <a:srgbClr val="C4D2EB"/>
             </a:solidFill>
           </a:ln>
         </p:spPr>
@@ -4204,7 +4204,7 @@
             <a:avLst/>
           </a:prstGeom>
           <a:solidFill>
-            <a:srgbClr val="165B35"/>
+            <a:srgbClr val="DCFCE7"/>
           </a:solidFill>
           <a:ln>
             <a:noFill/>
@@ -4258,7 +4258,7 @@
             <a:r>
               <a:rPr sz="1000" b="1" i="0">
                 <a:solidFill>
-                  <a:srgbClr val="22C55E"/>
+                  <a:srgbClr val="16803D"/>
                 </a:solidFill>
               </a:rPr>
               <a:t>G</a:t>
@@ -4292,7 +4292,7 @@
             <a:r>
               <a:rPr sz="900" b="1" i="0">
                 <a:solidFill>
-                  <a:srgbClr val="FFFFFF"/>
+                  <a:srgbClr val="0F172A"/>
                 </a:solidFill>
               </a:rPr>
               <a:t>Cost</a:t>
@@ -4315,11 +4315,11 @@
             <a:avLst/>
           </a:prstGeom>
           <a:solidFill>
-            <a:srgbClr val="22263A"/>
+            <a:srgbClr val="E5EEFC"/>
           </a:solidFill>
           <a:ln w="9525">
             <a:solidFill>
-              <a:srgbClr val="2E3350"/>
+              <a:srgbClr val="C4D2EB"/>
             </a:solidFill>
           </a:ln>
         </p:spPr>
@@ -4360,7 +4360,7 @@
             <a:avLst/>
           </a:prstGeom>
           <a:solidFill>
-            <a:srgbClr val="165B35"/>
+            <a:srgbClr val="DCFCE7"/>
           </a:solidFill>
           <a:ln>
             <a:noFill/>
@@ -4414,7 +4414,7 @@
             <a:r>
               <a:rPr sz="1000" b="1" i="0">
                 <a:solidFill>
-                  <a:srgbClr val="22C55E"/>
+                  <a:srgbClr val="16803D"/>
                 </a:solidFill>
               </a:rPr>
               <a:t>G</a:t>
@@ -4448,7 +4448,7 @@
             <a:r>
               <a:rPr sz="900" b="1" i="0">
                 <a:solidFill>
-                  <a:srgbClr val="FFFFFF"/>
+                  <a:srgbClr val="0F172A"/>
                 </a:solidFill>
               </a:rPr>
               <a:t>Risk</a:t>
@@ -4471,11 +4471,11 @@
             <a:avLst/>
           </a:prstGeom>
           <a:solidFill>
-            <a:srgbClr val="22263A"/>
+            <a:srgbClr val="E5EEFC"/>
           </a:solidFill>
           <a:ln w="9525">
             <a:solidFill>
-              <a:srgbClr val="2E3350"/>
+              <a:srgbClr val="C4D2EB"/>
             </a:solidFill>
           </a:ln>
         </p:spPr>
@@ -4516,7 +4516,7 @@
             <a:avLst/>
           </a:prstGeom>
           <a:solidFill>
-            <a:srgbClr val="7A1D1D"/>
+            <a:srgbClr val="FEE2E2"/>
           </a:solidFill>
           <a:ln>
             <a:noFill/>
@@ -4570,7 +4570,7 @@
             <a:r>
               <a:rPr sz="1000" b="1" i="0">
                 <a:solidFill>
-                  <a:srgbClr val="EF4444"/>
+                  <a:srgbClr val="DC2626"/>
                 </a:solidFill>
               </a:rPr>
               <a:t>R</a:t>
@@ -4604,7 +4604,7 @@
             <a:r>
               <a:rPr sz="900" b="1" i="0">
                 <a:solidFill>
-                  <a:srgbClr val="FFFFFF"/>
+                  <a:srgbClr val="0F172A"/>
                 </a:solidFill>
               </a:rPr>
               <a:t>Quality</a:t>
@@ -4627,11 +4627,11 @@
             <a:avLst/>
           </a:prstGeom>
           <a:solidFill>
-            <a:srgbClr val="22263A"/>
+            <a:srgbClr val="E5EEFC"/>
           </a:solidFill>
           <a:ln w="9525">
             <a:solidFill>
-              <a:srgbClr val="2E3350"/>
+              <a:srgbClr val="C4D2EB"/>
             </a:solidFill>
           </a:ln>
         </p:spPr>
@@ -4672,7 +4672,7 @@
             <a:avLst/>
           </a:prstGeom>
           <a:solidFill>
-            <a:srgbClr val="784B05"/>
+            <a:srgbClr val="FEF3C7"/>
           </a:solidFill>
           <a:ln>
             <a:noFill/>
@@ -4726,7 +4726,7 @@
             <a:r>
               <a:rPr sz="1000" b="1" i="0">
                 <a:solidFill>
-                  <a:srgbClr val="F59E0B"/>
+                  <a:srgbClr val="D97706"/>
                 </a:solidFill>
               </a:rPr>
               <a:t>Y</a:t>
@@ -4760,7 +4760,7 @@
             <a:r>
               <a:rPr sz="900" b="1" i="0">
                 <a:solidFill>
-                  <a:srgbClr val="FFFFFF"/>
+                  <a:srgbClr val="0F172A"/>
                 </a:solidFill>
               </a:rPr>
               <a:t>Resources</a:t>
@@ -4783,11 +4783,11 @@
             <a:avLst/>
           </a:prstGeom>
           <a:solidFill>
-            <a:srgbClr val="784B05"/>
+            <a:srgbClr val="FEF3C7"/>
           </a:solidFill>
           <a:ln w="9525">
             <a:solidFill>
-              <a:srgbClr val="F59E0B"/>
+              <a:srgbClr val="D97706"/>
             </a:solidFill>
           </a:ln>
         </p:spPr>
@@ -4839,7 +4839,7 @@
             <a:r>
               <a:rPr sz="800" b="1" i="0">
                 <a:solidFill>
-                  <a:srgbClr val="F59E0B"/>
+                  <a:srgbClr val="D97706"/>
                 </a:solidFill>
               </a:rPr>
               <a:t>⚠  WHY YELLOW?</a:t>
@@ -4873,7 +4873,7 @@
             <a:r>
               <a:rPr sz="950" b="0" i="0">
                 <a:solidFill>
-                  <a:srgbClr val="FFFFFF"/>
+                  <a:srgbClr val="0F172A"/>
                 </a:solidFill>
               </a:rPr>
               <a:t>Environment and resource changes have been identified during the reporting period. These changes are not expected to impact overall project delivery. The team is actively hiring a Tech Lead to prevent future environmental and build blockers, as key agency technical resources are engaged in other internal initiatives.</a:t>
@@ -4897,7 +4897,7 @@
           </a:prstGeom>
           <a:ln w="6350">
             <a:solidFill>
-              <a:srgbClr val="2E3350"/>
+              <a:srgbClr val="C4D2EB"/>
             </a:solidFill>
           </a:ln>
         </p:spPr>
@@ -4942,7 +4942,7 @@
             <a:r>
               <a:rPr sz="850" b="0" i="0">
                 <a:solidFill>
-                  <a:srgbClr val="8F96B3"/>
+                  <a:srgbClr val="4A5A82"/>
                 </a:solidFill>
               </a:rPr>
               <a:t>Reporting Period: FY26  ·  Jun 12, 2026</a:t>
@@ -4964,7 +4964,7 @@
     <p:bg>
       <p:bgPr>
         <a:solidFill>
-          <a:srgbClr val="0F1117"/>
+          <a:srgbClr val="F0F6FF"/>
         </a:solidFill>
         <a:effectLst/>
       </p:bgPr>
@@ -4991,7 +4991,7 @@
             <a:avLst/>
           </a:prstGeom>
           <a:solidFill>
-            <a:srgbClr val="1A1D27"/>
+            <a:srgbClr val="FFFFFF"/>
           </a:solidFill>
           <a:ln>
             <a:noFill/>
@@ -5045,7 +5045,7 @@
             <a:r>
               <a:rPr sz="1600" b="1" i="0">
                 <a:solidFill>
-                  <a:srgbClr val="FFFFFF"/>
+                  <a:srgbClr val="0F172A"/>
                 </a:solidFill>
               </a:rPr>
               <a:t>Sprint Schedule &amp; Delivery Milestones</a:t>
@@ -5068,7 +5068,7 @@
             <a:avLst/>
           </a:prstGeom>
           <a:solidFill>
-            <a:srgbClr val="1E3A7A"/>
+            <a:srgbClr val="DBEAFE"/>
           </a:solidFill>
           <a:ln>
             <a:noFill/>
@@ -5122,7 +5122,7 @@
             <a:r>
               <a:rPr sz="900" b="1" i="0">
                 <a:solidFill>
-                  <a:srgbClr val="4F8EF7"/>
+                  <a:srgbClr val="2563EB"/>
                 </a:solidFill>
               </a:rPr>
               <a:t>Sprint 2: IN PROGRESS</a:t>
@@ -5145,11 +5145,11 @@
             <a:avLst/>
           </a:prstGeom>
           <a:solidFill>
-            <a:srgbClr val="1A1D27"/>
+            <a:srgbClr val="FFFFFF"/>
           </a:solidFill>
           <a:ln w="9525">
             <a:solidFill>
-              <a:srgbClr val="2E3350"/>
+              <a:srgbClr val="C4D2EB"/>
             </a:solidFill>
           </a:ln>
         </p:spPr>
@@ -5201,7 +5201,7 @@
             <a:r>
               <a:rPr sz="1100" b="1" i="0">
                 <a:solidFill>
-                  <a:srgbClr val="FFFFFF"/>
+                  <a:srgbClr val="0F172A"/>
                 </a:solidFill>
               </a:rPr>
               <a:t>Sprint 1</a:t>
@@ -5235,7 +5235,7 @@
             <a:r>
               <a:rPr sz="800" b="0" i="0">
                 <a:solidFill>
-                  <a:srgbClr val="8F96B3"/>
+                  <a:srgbClr val="4A5A82"/>
                 </a:solidFill>
               </a:rPr>
               <a:t>Jun 17 – Jun 30, 2026</a:t>
@@ -5269,7 +5269,7 @@
             <a:r>
               <a:rPr sz="900" b="0" i="0">
                 <a:solidFill>
-                  <a:srgbClr val="FFFFFF"/>
+                  <a:srgbClr val="0F172A"/>
                 </a:solidFill>
               </a:rPr>
               <a:t>Group 3–9: PDF Portal Submissions &amp; Electronic Payments enabled</a:t>
@@ -5292,7 +5292,7 @@
             <a:avLst/>
           </a:prstGeom>
           <a:solidFill>
-            <a:srgbClr val="2E3350"/>
+            <a:srgbClr val="C4D2EB"/>
           </a:solidFill>
           <a:ln>
             <a:noFill/>
@@ -5335,7 +5335,7 @@
             <a:avLst/>
           </a:prstGeom>
           <a:solidFill>
-            <a:srgbClr val="22C55E"/>
+            <a:srgbClr val="16803D"/>
           </a:solidFill>
           <a:ln>
             <a:noFill/>
@@ -5389,7 +5389,7 @@
             <a:r>
               <a:rPr sz="800" b="1" i="0">
                 <a:solidFill>
-                  <a:srgbClr val="FFFFFF"/>
+                  <a:srgbClr val="0F172A"/>
                 </a:solidFill>
               </a:rPr>
               <a:t>100%</a:t>
@@ -5412,7 +5412,7 @@
             <a:avLst/>
           </a:prstGeom>
           <a:solidFill>
-            <a:srgbClr val="165B35"/>
+            <a:srgbClr val="DCFCE7"/>
           </a:solidFill>
           <a:ln>
             <a:noFill/>
@@ -5466,7 +5466,7 @@
             <a:r>
               <a:rPr sz="750" b="1" i="0">
                 <a:solidFill>
-                  <a:srgbClr val="22C55E"/>
+                  <a:srgbClr val="16803D"/>
                 </a:solidFill>
               </a:rPr>
               <a:t>Complete</a:t>
@@ -5489,11 +5489,11 @@
             <a:avLst/>
           </a:prstGeom>
           <a:solidFill>
-            <a:srgbClr val="1A1D27"/>
+            <a:srgbClr val="FFFFFF"/>
           </a:solidFill>
           <a:ln w="9525">
             <a:solidFill>
-              <a:srgbClr val="2E3350"/>
+              <a:srgbClr val="C4D2EB"/>
             </a:solidFill>
           </a:ln>
         </p:spPr>
@@ -5545,7 +5545,7 @@
             <a:r>
               <a:rPr sz="1100" b="1" i="0">
                 <a:solidFill>
-                  <a:srgbClr val="FFFFFF"/>
+                  <a:srgbClr val="0F172A"/>
                 </a:solidFill>
               </a:rPr>
               <a:t>Sprint 2</a:t>
@@ -5579,7 +5579,7 @@
             <a:r>
               <a:rPr sz="800" b="0" i="0">
                 <a:solidFill>
-                  <a:srgbClr val="8F96B3"/>
+                  <a:srgbClr val="4A5A82"/>
                 </a:solidFill>
               </a:rPr>
               <a:t>Jul 1 – Jul 14, 2026</a:t>
@@ -5613,7 +5613,7 @@
             <a:r>
               <a:rPr sz="900" b="0" i="0">
                 <a:solidFill>
-                  <a:srgbClr val="FFFFFF"/>
+                  <a:srgbClr val="0F172A"/>
                 </a:solidFill>
               </a:rPr>
               <a:t>Group 3–9: Enable Notifications for customers &amp; RHP Team Inbox</a:t>
@@ -5636,7 +5636,7 @@
             <a:avLst/>
           </a:prstGeom>
           <a:solidFill>
-            <a:srgbClr val="2E3350"/>
+            <a:srgbClr val="C4D2EB"/>
           </a:solidFill>
           <a:ln>
             <a:noFill/>
@@ -5679,7 +5679,7 @@
             <a:avLst/>
           </a:prstGeom>
           <a:solidFill>
-            <a:srgbClr val="4F8EF7"/>
+            <a:srgbClr val="2563EB"/>
           </a:solidFill>
           <a:ln>
             <a:noFill/>
@@ -5733,7 +5733,7 @@
             <a:r>
               <a:rPr sz="800" b="1" i="0">
                 <a:solidFill>
-                  <a:srgbClr val="FFFFFF"/>
+                  <a:srgbClr val="0F172A"/>
                 </a:solidFill>
               </a:rPr>
               <a:t>64%</a:t>
@@ -5756,7 +5756,7 @@
             <a:avLst/>
           </a:prstGeom>
           <a:solidFill>
-            <a:srgbClr val="1E3A7A"/>
+            <a:srgbClr val="DBEAFE"/>
           </a:solidFill>
           <a:ln>
             <a:noFill/>
@@ -5810,7 +5810,7 @@
             <a:r>
               <a:rPr sz="750" b="1" i="0">
                 <a:solidFill>
-                  <a:srgbClr val="4F8EF7"/>
+                  <a:srgbClr val="2563EB"/>
                 </a:solidFill>
               </a:rPr>
               <a:t>In Progress</a:t>
@@ -5833,11 +5833,11 @@
             <a:avLst/>
           </a:prstGeom>
           <a:solidFill>
-            <a:srgbClr val="1A1D27"/>
+            <a:srgbClr val="FFFFFF"/>
           </a:solidFill>
           <a:ln w="9525">
             <a:solidFill>
-              <a:srgbClr val="2E3350"/>
+              <a:srgbClr val="C4D2EB"/>
             </a:solidFill>
           </a:ln>
         </p:spPr>
@@ -5889,7 +5889,7 @@
             <a:r>
               <a:rPr sz="1100" b="1" i="0">
                 <a:solidFill>
-                  <a:srgbClr val="FFFFFF"/>
+                  <a:srgbClr val="0F172A"/>
                 </a:solidFill>
               </a:rPr>
               <a:t>Sprint 3</a:t>
@@ -5923,7 +5923,7 @@
             <a:r>
               <a:rPr sz="800" b="0" i="0">
                 <a:solidFill>
-                  <a:srgbClr val="8F96B3"/>
+                  <a:srgbClr val="4A5A82"/>
                 </a:solidFill>
               </a:rPr>
               <a:t>Jul 15 – Jul 28, 2026</a:t>
@@ -5957,7 +5957,7 @@
             <a:r>
               <a:rPr sz="900" b="0" i="0">
                 <a:solidFill>
-                  <a:srgbClr val="FFFFFF"/>
+                  <a:srgbClr val="0F172A"/>
                 </a:solidFill>
               </a:rPr>
               <a:t>Group 3–9: Provide option to download RHP permits</a:t>
@@ -5980,7 +5980,7 @@
             <a:avLst/>
           </a:prstGeom>
           <a:solidFill>
-            <a:srgbClr val="2E3350"/>
+            <a:srgbClr val="C4D2EB"/>
           </a:solidFill>
           <a:ln>
             <a:noFill/>
@@ -6034,7 +6034,7 @@
             <a:r>
               <a:rPr sz="800" b="1" i="0">
                 <a:solidFill>
-                  <a:srgbClr val="FFFFFF"/>
+                  <a:srgbClr val="0F172A"/>
                 </a:solidFill>
               </a:rPr>
               <a:t>0%</a:t>
@@ -6057,7 +6057,7 @@
             <a:avLst/>
           </a:prstGeom>
           <a:solidFill>
-            <a:srgbClr val="22263A"/>
+            <a:srgbClr val="E5EEFC"/>
           </a:solidFill>
           <a:ln>
             <a:noFill/>
@@ -6111,7 +6111,7 @@
             <a:r>
               <a:rPr sz="750" b="1" i="0">
                 <a:solidFill>
-                  <a:srgbClr val="8F96B3"/>
+                  <a:srgbClr val="4A5A82"/>
                 </a:solidFill>
               </a:rPr>
               <a:t>Not Started</a:t>
@@ -6134,11 +6134,11 @@
             <a:avLst/>
           </a:prstGeom>
           <a:solidFill>
-            <a:srgbClr val="1A1D27"/>
+            <a:srgbClr val="FFFFFF"/>
           </a:solidFill>
           <a:ln w="9525">
             <a:solidFill>
-              <a:srgbClr val="2E3350"/>
+              <a:srgbClr val="C4D2EB"/>
             </a:solidFill>
           </a:ln>
         </p:spPr>
@@ -6190,7 +6190,7 @@
             <a:r>
               <a:rPr sz="1100" b="1" i="0">
                 <a:solidFill>
-                  <a:srgbClr val="FFFFFF"/>
+                  <a:srgbClr val="0F172A"/>
                 </a:solidFill>
               </a:rPr>
               <a:t>Sprint 4</a:t>
@@ -6224,7 +6224,7 @@
             <a:r>
               <a:rPr sz="800" b="0" i="0">
                 <a:solidFill>
-                  <a:srgbClr val="8F96B3"/>
+                  <a:srgbClr val="4A5A82"/>
                 </a:solidFill>
               </a:rPr>
               <a:t>Jul 29 – Aug 11, 2026</a:t>
@@ -6258,7 +6258,7 @@
             <a:r>
               <a:rPr sz="900" b="0" i="0">
                 <a:solidFill>
-                  <a:srgbClr val="FFFFFF"/>
+                  <a:srgbClr val="0F172A"/>
                 </a:solidFill>
               </a:rPr>
               <a:t>Group 3–9: Reject &amp; update status (CRM) for RHP permits</a:t>
@@ -6281,7 +6281,7 @@
             <a:avLst/>
           </a:prstGeom>
           <a:solidFill>
-            <a:srgbClr val="2E3350"/>
+            <a:srgbClr val="C4D2EB"/>
           </a:solidFill>
           <a:ln>
             <a:noFill/>
@@ -6335,7 +6335,7 @@
             <a:r>
               <a:rPr sz="800" b="1" i="0">
                 <a:solidFill>
-                  <a:srgbClr val="FFFFFF"/>
+                  <a:srgbClr val="0F172A"/>
                 </a:solidFill>
               </a:rPr>
               <a:t>0%</a:t>
@@ -6358,7 +6358,7 @@
             <a:avLst/>
           </a:prstGeom>
           <a:solidFill>
-            <a:srgbClr val="22263A"/>
+            <a:srgbClr val="E5EEFC"/>
           </a:solidFill>
           <a:ln>
             <a:noFill/>
@@ -6412,7 +6412,7 @@
             <a:r>
               <a:rPr sz="750" b="1" i="0">
                 <a:solidFill>
-                  <a:srgbClr val="8F96B3"/>
+                  <a:srgbClr val="4A5A82"/>
                 </a:solidFill>
               </a:rPr>
               <a:t>Not Started</a:t>
@@ -6435,11 +6435,11 @@
             <a:avLst/>
           </a:prstGeom>
           <a:solidFill>
-            <a:srgbClr val="1A1D27"/>
+            <a:srgbClr val="FFFFFF"/>
           </a:solidFill>
           <a:ln w="9525">
             <a:solidFill>
-              <a:srgbClr val="2E3350"/>
+              <a:srgbClr val="C4D2EB"/>
             </a:solidFill>
           </a:ln>
         </p:spPr>
@@ -6491,7 +6491,7 @@
             <a:r>
               <a:rPr sz="1100" b="1" i="0">
                 <a:solidFill>
-                  <a:srgbClr val="FFFFFF"/>
+                  <a:srgbClr val="0F172A"/>
                 </a:solidFill>
               </a:rPr>
               <a:t>Sprint 5</a:t>
@@ -6525,7 +6525,7 @@
             <a:r>
               <a:rPr sz="800" b="0" i="0">
                 <a:solidFill>
-                  <a:srgbClr val="8F96B3"/>
+                  <a:srgbClr val="4A5A82"/>
                 </a:solidFill>
               </a:rPr>
               <a:t>TBD</a:t>
@@ -6559,7 +6559,7 @@
             <a:r>
               <a:rPr sz="900" b="0" i="0">
                 <a:solidFill>
-                  <a:srgbClr val="FFFFFF"/>
+                  <a:srgbClr val="0F172A"/>
                 </a:solidFill>
               </a:rPr>
               <a:t>Group 1–2: Configuration and setup</a:t>
@@ -6582,7 +6582,7 @@
             <a:avLst/>
           </a:prstGeom>
           <a:solidFill>
-            <a:srgbClr val="2E3350"/>
+            <a:srgbClr val="C4D2EB"/>
           </a:solidFill>
           <a:ln>
             <a:noFill/>
@@ -6636,7 +6636,7 @@
             <a:r>
               <a:rPr sz="800" b="1" i="0">
                 <a:solidFill>
-                  <a:srgbClr val="FFFFFF"/>
+                  <a:srgbClr val="0F172A"/>
                 </a:solidFill>
               </a:rPr>
               <a:t>0%</a:t>
@@ -6659,7 +6659,7 @@
             <a:avLst/>
           </a:prstGeom>
           <a:solidFill>
-            <a:srgbClr val="22263A"/>
+            <a:srgbClr val="E5EEFC"/>
           </a:solidFill>
           <a:ln>
             <a:noFill/>
@@ -6713,7 +6713,7 @@
             <a:r>
               <a:rPr sz="750" b="1" i="0">
                 <a:solidFill>
-                  <a:srgbClr val="8F96B3"/>
+                  <a:srgbClr val="4A5A82"/>
                 </a:solidFill>
               </a:rPr>
               <a:t>Not Started</a:t>
@@ -6736,11 +6736,11 @@
             <a:avLst/>
           </a:prstGeom>
           <a:solidFill>
-            <a:srgbClr val="1A1D27"/>
+            <a:srgbClr val="FFFFFF"/>
           </a:solidFill>
           <a:ln w="9525">
             <a:solidFill>
-              <a:srgbClr val="2E3350"/>
+              <a:srgbClr val="C4D2EB"/>
             </a:solidFill>
           </a:ln>
         </p:spPr>
@@ -6792,7 +6792,7 @@
             <a:r>
               <a:rPr sz="1100" b="1" i="0">
                 <a:solidFill>
-                  <a:srgbClr val="FFFFFF"/>
+                  <a:srgbClr val="0F172A"/>
                 </a:solidFill>
               </a:rPr>
               <a:t>Sprint 6</a:t>
@@ -6826,7 +6826,7 @@
             <a:r>
               <a:rPr sz="800" b="0" i="0">
                 <a:solidFill>
-                  <a:srgbClr val="8F96B3"/>
+                  <a:srgbClr val="4A5A82"/>
                 </a:solidFill>
               </a:rPr>
               <a:t>TBD</a:t>
@@ -6860,7 +6860,7 @@
             <a:r>
               <a:rPr sz="900" b="0" i="0">
                 <a:solidFill>
-                  <a:srgbClr val="FFFFFF"/>
+                  <a:srgbClr val="0F172A"/>
                 </a:solidFill>
               </a:rPr>
               <a:t>Group 3–9: Web Forms Development</a:t>
@@ -6883,7 +6883,7 @@
             <a:avLst/>
           </a:prstGeom>
           <a:solidFill>
-            <a:srgbClr val="2E3350"/>
+            <a:srgbClr val="C4D2EB"/>
           </a:solidFill>
           <a:ln>
             <a:noFill/>
@@ -6937,7 +6937,7 @@
             <a:r>
               <a:rPr sz="800" b="1" i="0">
                 <a:solidFill>
-                  <a:srgbClr val="FFFFFF"/>
+                  <a:srgbClr val="0F172A"/>
                 </a:solidFill>
               </a:rPr>
               <a:t>0%</a:t>
@@ -6960,7 +6960,7 @@
             <a:avLst/>
           </a:prstGeom>
           <a:solidFill>
-            <a:srgbClr val="22263A"/>
+            <a:srgbClr val="E5EEFC"/>
           </a:solidFill>
           <a:ln>
             <a:noFill/>
@@ -7014,7 +7014,7 @@
             <a:r>
               <a:rPr sz="750" b="1" i="0">
                 <a:solidFill>
-                  <a:srgbClr val="8F96B3"/>
+                  <a:srgbClr val="4A5A82"/>
                 </a:solidFill>
               </a:rPr>
               <a:t>Not Started</a:t>
@@ -7038,7 +7038,7 @@
           </a:prstGeom>
           <a:ln w="6350">
             <a:solidFill>
-              <a:srgbClr val="2E3350"/>
+              <a:srgbClr val="C4D2EB"/>
             </a:solidFill>
           </a:ln>
         </p:spPr>
@@ -7083,7 +7083,7 @@
             <a:r>
               <a:rPr sz="800" b="0" i="0">
                 <a:solidFill>
-                  <a:srgbClr val="8F96B3"/>
+                  <a:srgbClr val="4A5A82"/>
                 </a:solidFill>
               </a:rPr>
               <a:t>Near = within 2 sprints  ·  Next = planned future sprints</a:t>
@@ -7105,7 +7105,7 @@
     <p:bg>
       <p:bgPr>
         <a:solidFill>
-          <a:srgbClr val="0F1117"/>
+          <a:srgbClr val="F0F6FF"/>
         </a:solidFill>
         <a:effectLst/>
       </p:bgPr>
@@ -7132,7 +7132,7 @@
             <a:avLst/>
           </a:prstGeom>
           <a:solidFill>
-            <a:srgbClr val="1A1D27"/>
+            <a:srgbClr val="FFFFFF"/>
           </a:solidFill>
           <a:ln>
             <a:noFill/>
@@ -7186,7 +7186,7 @@
             <a:r>
               <a:rPr sz="1600" b="1" i="0">
                 <a:solidFill>
-                  <a:srgbClr val="FFFFFF"/>
+                  <a:srgbClr val="0F172A"/>
                 </a:solidFill>
               </a:rPr>
               <a:t>Financial Summary</a:t>
@@ -7209,7 +7209,7 @@
             <a:avLst/>
           </a:prstGeom>
           <a:solidFill>
-            <a:srgbClr val="165B35"/>
+            <a:srgbClr val="DCFCE7"/>
           </a:solidFill>
           <a:ln>
             <a:noFill/>
@@ -7263,7 +7263,7 @@
             <a:r>
               <a:rPr sz="900" b="1" i="0">
                 <a:solidFill>
-                  <a:srgbClr val="22C55E"/>
+                  <a:srgbClr val="16803D"/>
                 </a:solidFill>
               </a:rPr>
               <a:t>Cost Status: GREEN</a:t>
@@ -7286,11 +7286,11 @@
             <a:avLst/>
           </a:prstGeom>
           <a:solidFill>
-            <a:srgbClr val="1E3A7A"/>
+            <a:srgbClr val="DBEAFE"/>
           </a:solidFill>
           <a:ln w="9525">
             <a:solidFill>
-              <a:srgbClr val="4F8EF7"/>
+              <a:srgbClr val="2563EB"/>
             </a:solidFill>
           </a:ln>
         </p:spPr>
@@ -7342,7 +7342,7 @@
             <a:r>
               <a:rPr sz="750" b="1" i="0">
                 <a:solidFill>
-                  <a:srgbClr val="8F96B3"/>
+                  <a:srgbClr val="4A5A82"/>
                 </a:solidFill>
               </a:rPr>
               <a:t>Total Approved</a:t>
@@ -7376,7 +7376,7 @@
             <a:r>
               <a:rPr sz="2000" b="1" i="0">
                 <a:solidFill>
-                  <a:srgbClr val="4F8EF7"/>
+                  <a:srgbClr val="2563EB"/>
                 </a:solidFill>
               </a:rPr>
               <a:t>$6.0M</a:t>
@@ -7410,7 +7410,7 @@
             <a:r>
               <a:rPr sz="750" b="0" i="0">
                 <a:solidFill>
-                  <a:srgbClr val="8F96B3"/>
+                  <a:srgbClr val="4A5A82"/>
                 </a:solidFill>
               </a:rPr>
               <a:t>FY25–FY26 Combined</a:t>
@@ -7433,11 +7433,11 @@
             <a:avLst/>
           </a:prstGeom>
           <a:solidFill>
-            <a:srgbClr val="784B05"/>
+            <a:srgbClr val="FEF3C7"/>
           </a:solidFill>
           <a:ln w="9525">
             <a:solidFill>
-              <a:srgbClr val="F59E0B"/>
+              <a:srgbClr val="D97706"/>
             </a:solidFill>
           </a:ln>
         </p:spPr>
@@ -7489,7 +7489,7 @@
             <a:r>
               <a:rPr sz="750" b="1" i="0">
                 <a:solidFill>
-                  <a:srgbClr val="8F96B3"/>
+                  <a:srgbClr val="4A5A82"/>
                 </a:solidFill>
               </a:rPr>
               <a:t>Total Forecast</a:t>
@@ -7523,7 +7523,7 @@
             <a:r>
               <a:rPr sz="2000" b="1" i="0">
                 <a:solidFill>
-                  <a:srgbClr val="F59E0B"/>
+                  <a:srgbClr val="D97706"/>
                 </a:solidFill>
               </a:rPr>
               <a:t>$3.70M</a:t>
@@ -7557,7 +7557,7 @@
             <a:r>
               <a:rPr sz="750" b="0" i="0">
                 <a:solidFill>
-                  <a:srgbClr val="8F96B3"/>
+                  <a:srgbClr val="4A5A82"/>
                 </a:solidFill>
               </a:rPr>
               <a:t>FY25–FY28 All Years</a:t>
@@ -7580,11 +7580,11 @@
             <a:avLst/>
           </a:prstGeom>
           <a:solidFill>
-            <a:srgbClr val="165B35"/>
+            <a:srgbClr val="DCFCE7"/>
           </a:solidFill>
           <a:ln w="9525">
             <a:solidFill>
-              <a:srgbClr val="22C55E"/>
+              <a:srgbClr val="16803D"/>
             </a:solidFill>
           </a:ln>
         </p:spPr>
@@ -7636,7 +7636,7 @@
             <a:r>
               <a:rPr sz="750" b="1" i="0">
                 <a:solidFill>
-                  <a:srgbClr val="8F96B3"/>
+                  <a:srgbClr val="4A5A82"/>
                 </a:solidFill>
               </a:rPr>
               <a:t>Total Actual</a:t>
@@ -7670,7 +7670,7 @@
             <a:r>
               <a:rPr sz="2000" b="1" i="0">
                 <a:solidFill>
-                  <a:srgbClr val="22C55E"/>
+                  <a:srgbClr val="16803D"/>
                 </a:solidFill>
               </a:rPr>
               <a:t>$1.45M</a:t>
@@ -7704,7 +7704,7 @@
             <a:r>
               <a:rPr sz="750" b="0" i="0">
                 <a:solidFill>
-                  <a:srgbClr val="8F96B3"/>
+                  <a:srgbClr val="4A5A82"/>
                 </a:solidFill>
               </a:rPr>
               <a:t>FY25 + FY26 Spent</a:t>
@@ -7727,11 +7727,11 @@
             <a:avLst/>
           </a:prstGeom>
           <a:solidFill>
-            <a:srgbClr val="4A1F78"/>
+            <a:srgbClr val="EDE9FE"/>
           </a:solidFill>
           <a:ln w="9525">
             <a:solidFill>
-              <a:srgbClr val="A855F7"/>
+              <a:srgbClr val="6D28D9"/>
             </a:solidFill>
           </a:ln>
         </p:spPr>
@@ -7783,7 +7783,7 @@
             <a:r>
               <a:rPr sz="750" b="1" i="0">
                 <a:solidFill>
-                  <a:srgbClr val="8F96B3"/>
+                  <a:srgbClr val="4A5A82"/>
                 </a:solidFill>
               </a:rPr>
               <a:t>Remaining</a:t>
@@ -7817,7 +7817,7 @@
             <a:r>
               <a:rPr sz="2000" b="1" i="0">
                 <a:solidFill>
-                  <a:srgbClr val="A855F7"/>
+                  <a:srgbClr val="6D28D9"/>
                 </a:solidFill>
               </a:rPr>
               <a:t>$1.55M</a:t>
@@ -7851,7 +7851,7 @@
             <a:r>
               <a:rPr sz="750" b="0" i="0">
                 <a:solidFill>
-                  <a:srgbClr val="8F96B3"/>
+                  <a:srgbClr val="4A5A82"/>
                 </a:solidFill>
               </a:rPr>
               <a:t>Balance / Variance</a:t>
@@ -7874,7 +7874,7 @@
             <a:avLst/>
           </a:prstGeom>
           <a:solidFill>
-            <a:srgbClr val="0E1225"/>
+            <a:srgbClr val="DBEAFE"/>
           </a:solidFill>
           <a:ln>
             <a:noFill/>
@@ -7928,7 +7928,7 @@
             <a:r>
               <a:rPr sz="750" b="1" i="0">
                 <a:solidFill>
-                  <a:srgbClr val="8F96B3"/>
+                  <a:srgbClr val="4A5A82"/>
                 </a:solidFill>
               </a:rPr>
               <a:t>Fiscal Year</a:t>
@@ -7951,7 +7951,7 @@
             <a:avLst/>
           </a:prstGeom>
           <a:solidFill>
-            <a:srgbClr val="0E1225"/>
+            <a:srgbClr val="DBEAFE"/>
           </a:solidFill>
           <a:ln>
             <a:noFill/>
@@ -8005,7 +8005,7 @@
             <a:r>
               <a:rPr sz="750" b="1" i="0">
                 <a:solidFill>
-                  <a:srgbClr val="8F96B3"/>
+                  <a:srgbClr val="4A5A82"/>
                 </a:solidFill>
               </a:rPr>
               <a:t>Approved</a:t>
@@ -8028,7 +8028,7 @@
             <a:avLst/>
           </a:prstGeom>
           <a:solidFill>
-            <a:srgbClr val="0E1225"/>
+            <a:srgbClr val="DBEAFE"/>
           </a:solidFill>
           <a:ln>
             <a:noFill/>
@@ -8082,7 +8082,7 @@
             <a:r>
               <a:rPr sz="750" b="1" i="0">
                 <a:solidFill>
-                  <a:srgbClr val="8F96B3"/>
+                  <a:srgbClr val="4A5A82"/>
                 </a:solidFill>
               </a:rPr>
               <a:t>Forecast</a:t>
@@ -8105,7 +8105,7 @@
             <a:avLst/>
           </a:prstGeom>
           <a:solidFill>
-            <a:srgbClr val="0E1225"/>
+            <a:srgbClr val="DBEAFE"/>
           </a:solidFill>
           <a:ln>
             <a:noFill/>
@@ -8159,7 +8159,7 @@
             <a:r>
               <a:rPr sz="750" b="1" i="0">
                 <a:solidFill>
-                  <a:srgbClr val="8F96B3"/>
+                  <a:srgbClr val="4A5A82"/>
                 </a:solidFill>
               </a:rPr>
               <a:t>Actual</a:t>
@@ -8182,7 +8182,7 @@
             <a:avLst/>
           </a:prstGeom>
           <a:solidFill>
-            <a:srgbClr val="0E1225"/>
+            <a:srgbClr val="DBEAFE"/>
           </a:solidFill>
           <a:ln>
             <a:noFill/>
@@ -8236,7 +8236,7 @@
             <a:r>
               <a:rPr sz="750" b="1" i="0">
                 <a:solidFill>
-                  <a:srgbClr val="8F96B3"/>
+                  <a:srgbClr val="4A5A82"/>
                 </a:solidFill>
               </a:rPr>
               <a:t>Balance</a:t>
@@ -8259,7 +8259,7 @@
             <a:avLst/>
           </a:prstGeom>
           <a:solidFill>
-            <a:srgbClr val="0E1225"/>
+            <a:srgbClr val="DBEAFE"/>
           </a:solidFill>
           <a:ln>
             <a:noFill/>
@@ -8313,7 +8313,7 @@
             <a:r>
               <a:rPr sz="750" b="1" i="0">
                 <a:solidFill>
-                  <a:srgbClr val="8F96B3"/>
+                  <a:srgbClr val="4A5A82"/>
                 </a:solidFill>
               </a:rPr>
               <a:t>Fund Source</a:t>
@@ -8336,11 +8336,11 @@
             <a:avLst/>
           </a:prstGeom>
           <a:solidFill>
-            <a:srgbClr val="1A1D27"/>
+            <a:srgbClr val="FFFFFF"/>
           </a:solidFill>
           <a:ln w="5080">
             <a:solidFill>
-              <a:srgbClr val="2E3350"/>
+              <a:srgbClr val="C4D2EB"/>
             </a:solidFill>
           </a:ln>
         </p:spPr>
@@ -8392,7 +8392,7 @@
             <a:r>
               <a:rPr sz="900" b="1" i="0">
                 <a:solidFill>
-                  <a:srgbClr val="FFFFFF"/>
+                  <a:srgbClr val="0F172A"/>
                 </a:solidFill>
               </a:rPr>
               <a:t>FY-25</a:t>
@@ -8415,11 +8415,11 @@
             <a:avLst/>
           </a:prstGeom>
           <a:solidFill>
-            <a:srgbClr val="1A1D27"/>
+            <a:srgbClr val="FFFFFF"/>
           </a:solidFill>
           <a:ln w="5080">
             <a:solidFill>
-              <a:srgbClr val="2E3350"/>
+              <a:srgbClr val="C4D2EB"/>
             </a:solidFill>
           </a:ln>
         </p:spPr>
@@ -8471,7 +8471,7 @@
             <a:r>
               <a:rPr sz="900" b="0" i="0">
                 <a:solidFill>
-                  <a:srgbClr val="8F96B3"/>
+                  <a:srgbClr val="0F172A"/>
                 </a:solidFill>
               </a:rPr>
               <a:t>$1,000,000</a:t>
@@ -8494,11 +8494,11 @@
             <a:avLst/>
           </a:prstGeom>
           <a:solidFill>
-            <a:srgbClr val="1A1D27"/>
+            <a:srgbClr val="FFFFFF"/>
           </a:solidFill>
           <a:ln w="5080">
             <a:solidFill>
-              <a:srgbClr val="2E3350"/>
+              <a:srgbClr val="C4D2EB"/>
             </a:solidFill>
           </a:ln>
         </p:spPr>
@@ -8550,7 +8550,7 @@
             <a:r>
               <a:rPr sz="900" b="0" i="0">
                 <a:solidFill>
-                  <a:srgbClr val="8F96B3"/>
+                  <a:srgbClr val="0F172A"/>
                 </a:solidFill>
               </a:rPr>
               <a:t>$500,000</a:t>
@@ -8573,11 +8573,11 @@
             <a:avLst/>
           </a:prstGeom>
           <a:solidFill>
-            <a:srgbClr val="1A1D27"/>
+            <a:srgbClr val="FFFFFF"/>
           </a:solidFill>
           <a:ln w="5080">
             <a:solidFill>
-              <a:srgbClr val="2E3350"/>
+              <a:srgbClr val="C4D2EB"/>
             </a:solidFill>
           </a:ln>
         </p:spPr>
@@ -8629,7 +8629,7 @@
             <a:r>
               <a:rPr sz="900" b="0" i="0">
                 <a:solidFill>
-                  <a:srgbClr val="8F96B3"/>
+                  <a:srgbClr val="0F172A"/>
                 </a:solidFill>
               </a:rPr>
               <a:t>$275,086</a:t>
@@ -8652,11 +8652,11 @@
             <a:avLst/>
           </a:prstGeom>
           <a:solidFill>
-            <a:srgbClr val="1A1D27"/>
+            <a:srgbClr val="FFFFFF"/>
           </a:solidFill>
           <a:ln w="5080">
             <a:solidFill>
-              <a:srgbClr val="2E3350"/>
+              <a:srgbClr val="C4D2EB"/>
             </a:solidFill>
           </a:ln>
         </p:spPr>
@@ -8708,7 +8708,7 @@
             <a:r>
               <a:rPr sz="900" b="1" i="0">
                 <a:solidFill>
-                  <a:srgbClr val="22C55E"/>
+                  <a:srgbClr val="16803D"/>
                 </a:solidFill>
               </a:rPr>
               <a:t>$724,914</a:t>
@@ -8731,11 +8731,11 @@
             <a:avLst/>
           </a:prstGeom>
           <a:solidFill>
-            <a:srgbClr val="1A1D27"/>
+            <a:srgbClr val="FFFFFF"/>
           </a:solidFill>
           <a:ln w="5080">
             <a:solidFill>
-              <a:srgbClr val="2E3350"/>
+              <a:srgbClr val="C4D2EB"/>
             </a:solidFill>
           </a:ln>
         </p:spPr>
@@ -8787,7 +8787,7 @@
             <a:r>
               <a:rPr sz="900" b="0" i="0">
                 <a:solidFill>
-                  <a:srgbClr val="8F96B3"/>
+                  <a:srgbClr val="0F172A"/>
                 </a:solidFill>
               </a:rPr>
               <a:t>Radiation Control (SF)</a:t>
@@ -8810,11 +8810,11 @@
             <a:avLst/>
           </a:prstGeom>
           <a:solidFill>
-            <a:srgbClr val="22263A"/>
+            <a:srgbClr val="E5EEFC"/>
           </a:solidFill>
           <a:ln w="5080">
             <a:solidFill>
-              <a:srgbClr val="2E3350"/>
+              <a:srgbClr val="C4D2EB"/>
             </a:solidFill>
           </a:ln>
         </p:spPr>
@@ -8866,7 +8866,7 @@
             <a:r>
               <a:rPr sz="900" b="1" i="0">
                 <a:solidFill>
-                  <a:srgbClr val="FFFFFF"/>
+                  <a:srgbClr val="0F172A"/>
                 </a:solidFill>
               </a:rPr>
               <a:t>FY-26</a:t>
@@ -8889,11 +8889,11 @@
             <a:avLst/>
           </a:prstGeom>
           <a:solidFill>
-            <a:srgbClr val="22263A"/>
+            <a:srgbClr val="E5EEFC"/>
           </a:solidFill>
           <a:ln w="5080">
             <a:solidFill>
-              <a:srgbClr val="2E3350"/>
+              <a:srgbClr val="C4D2EB"/>
             </a:solidFill>
           </a:ln>
         </p:spPr>
@@ -8945,7 +8945,7 @@
             <a:r>
               <a:rPr sz="900" b="0" i="0">
                 <a:solidFill>
-                  <a:srgbClr val="8F96B3"/>
+                  <a:srgbClr val="0F172A"/>
                 </a:solidFill>
               </a:rPr>
               <a:t>$2,000,000</a:t>
@@ -8968,11 +8968,11 @@
             <a:avLst/>
           </a:prstGeom>
           <a:solidFill>
-            <a:srgbClr val="22263A"/>
+            <a:srgbClr val="E5EEFC"/>
           </a:solidFill>
           <a:ln w="5080">
             <a:solidFill>
-              <a:srgbClr val="2E3350"/>
+              <a:srgbClr val="C4D2EB"/>
             </a:solidFill>
           </a:ln>
         </p:spPr>
@@ -9024,7 +9024,7 @@
             <a:r>
               <a:rPr sz="900" b="0" i="0">
                 <a:solidFill>
-                  <a:srgbClr val="8F96B3"/>
+                  <a:srgbClr val="0F172A"/>
                 </a:solidFill>
               </a:rPr>
               <a:t>$1,200,000</a:t>
@@ -9047,11 +9047,11 @@
             <a:avLst/>
           </a:prstGeom>
           <a:solidFill>
-            <a:srgbClr val="22263A"/>
+            <a:srgbClr val="E5EEFC"/>
           </a:solidFill>
           <a:ln w="5080">
             <a:solidFill>
-              <a:srgbClr val="2E3350"/>
+              <a:srgbClr val="C4D2EB"/>
             </a:solidFill>
           </a:ln>
         </p:spPr>
@@ -9103,7 +9103,7 @@
             <a:r>
               <a:rPr sz="900" b="0" i="0">
                 <a:solidFill>
-                  <a:srgbClr val="8F96B3"/>
+                  <a:srgbClr val="0F172A"/>
                 </a:solidFill>
               </a:rPr>
               <a:t>$1,177,504</a:t>
@@ -9126,11 +9126,11 @@
             <a:avLst/>
           </a:prstGeom>
           <a:solidFill>
-            <a:srgbClr val="22263A"/>
+            <a:srgbClr val="E5EEFC"/>
           </a:solidFill>
           <a:ln w="5080">
             <a:solidFill>
-              <a:srgbClr val="2E3350"/>
+              <a:srgbClr val="C4D2EB"/>
             </a:solidFill>
           </a:ln>
         </p:spPr>
@@ -9182,7 +9182,7 @@
             <a:r>
               <a:rPr sz="900" b="1" i="0">
                 <a:solidFill>
-                  <a:srgbClr val="22C55E"/>
+                  <a:srgbClr val="16803D"/>
                 </a:solidFill>
               </a:rPr>
               <a:t>$822,496</a:t>
@@ -9205,11 +9205,11 @@
             <a:avLst/>
           </a:prstGeom>
           <a:solidFill>
-            <a:srgbClr val="22263A"/>
+            <a:srgbClr val="E5EEFC"/>
           </a:solidFill>
           <a:ln w="5080">
             <a:solidFill>
-              <a:srgbClr val="2E3350"/>
+              <a:srgbClr val="C4D2EB"/>
             </a:solidFill>
           </a:ln>
         </p:spPr>
@@ -9261,7 +9261,7 @@
             <a:r>
               <a:rPr sz="900" b="0" i="0">
                 <a:solidFill>
-                  <a:srgbClr val="8F96B3"/>
+                  <a:srgbClr val="0F172A"/>
                 </a:solidFill>
               </a:rPr>
               <a:t>Radiation Control (SF)</a:t>
@@ -9284,11 +9284,11 @@
             <a:avLst/>
           </a:prstGeom>
           <a:solidFill>
-            <a:srgbClr val="1A1D27"/>
+            <a:srgbClr val="FFFFFF"/>
           </a:solidFill>
           <a:ln w="5080">
             <a:solidFill>
-              <a:srgbClr val="2E3350"/>
+              <a:srgbClr val="C4D2EB"/>
             </a:solidFill>
           </a:ln>
         </p:spPr>
@@ -9340,7 +9340,7 @@
             <a:r>
               <a:rPr sz="900" b="1" i="0">
                 <a:solidFill>
-                  <a:srgbClr val="FFFFFF"/>
+                  <a:srgbClr val="0F172A"/>
                 </a:solidFill>
               </a:rPr>
               <a:t>FY-27</a:t>
@@ -9363,11 +9363,11 @@
             <a:avLst/>
           </a:prstGeom>
           <a:solidFill>
-            <a:srgbClr val="1A1D27"/>
+            <a:srgbClr val="FFFFFF"/>
           </a:solidFill>
           <a:ln w="5080">
             <a:solidFill>
-              <a:srgbClr val="2E3350"/>
+              <a:srgbClr val="C4D2EB"/>
             </a:solidFill>
           </a:ln>
         </p:spPr>
@@ -9419,7 +9419,7 @@
             <a:r>
               <a:rPr sz="900" b="0" i="0">
                 <a:solidFill>
-                  <a:srgbClr val="8F96B3"/>
+                  <a:srgbClr val="0F172A"/>
                 </a:solidFill>
               </a:rPr>
               <a:t>$3,000,000</a:t>
@@ -9442,11 +9442,11 @@
             <a:avLst/>
           </a:prstGeom>
           <a:solidFill>
-            <a:srgbClr val="1A1D27"/>
+            <a:srgbClr val="FFFFFF"/>
           </a:solidFill>
           <a:ln w="5080">
             <a:solidFill>
-              <a:srgbClr val="2E3350"/>
+              <a:srgbClr val="C4D2EB"/>
             </a:solidFill>
           </a:ln>
         </p:spPr>
@@ -9498,7 +9498,7 @@
             <a:r>
               <a:rPr sz="900" b="0" i="0">
                 <a:solidFill>
-                  <a:srgbClr val="8F96B3"/>
+                  <a:srgbClr val="0F172A"/>
                 </a:solidFill>
               </a:rPr>
               <a:t>$1,468,511</a:t>
@@ -9521,11 +9521,11 @@
             <a:avLst/>
           </a:prstGeom>
           <a:solidFill>
-            <a:srgbClr val="1A1D27"/>
+            <a:srgbClr val="FFFFFF"/>
           </a:solidFill>
           <a:ln w="5080">
             <a:solidFill>
-              <a:srgbClr val="2E3350"/>
+              <a:srgbClr val="C4D2EB"/>
             </a:solidFill>
           </a:ln>
         </p:spPr>
@@ -9577,7 +9577,7 @@
             <a:r>
               <a:rPr sz="900" b="0" i="0">
                 <a:solidFill>
-                  <a:srgbClr val="8F96B3"/>
+                  <a:srgbClr val="0F172A"/>
                 </a:solidFill>
               </a:rPr>
               <a:t>—</a:t>
@@ -9600,11 +9600,11 @@
             <a:avLst/>
           </a:prstGeom>
           <a:solidFill>
-            <a:srgbClr val="1A1D27"/>
+            <a:srgbClr val="FFFFFF"/>
           </a:solidFill>
           <a:ln w="5080">
             <a:solidFill>
-              <a:srgbClr val="2E3350"/>
+              <a:srgbClr val="C4D2EB"/>
             </a:solidFill>
           </a:ln>
         </p:spPr>
@@ -9656,7 +9656,7 @@
             <a:r>
               <a:rPr sz="900" b="0" i="0">
                 <a:solidFill>
-                  <a:srgbClr val="8F96B3"/>
+                  <a:srgbClr val="0F172A"/>
                 </a:solidFill>
               </a:rPr>
               <a:t>$0</a:t>
@@ -9679,11 +9679,11 @@
             <a:avLst/>
           </a:prstGeom>
           <a:solidFill>
-            <a:srgbClr val="1A1D27"/>
+            <a:srgbClr val="FFFFFF"/>
           </a:solidFill>
           <a:ln w="5080">
             <a:solidFill>
-              <a:srgbClr val="2E3350"/>
+              <a:srgbClr val="C4D2EB"/>
             </a:solidFill>
           </a:ln>
         </p:spPr>
@@ -9735,7 +9735,7 @@
             <a:r>
               <a:rPr sz="900" b="0" i="0">
                 <a:solidFill>
-                  <a:srgbClr val="8F96B3"/>
+                  <a:srgbClr val="0F172A"/>
                 </a:solidFill>
               </a:rPr>
               <a:t>Special</a:t>
@@ -9758,11 +9758,11 @@
             <a:avLst/>
           </a:prstGeom>
           <a:solidFill>
-            <a:srgbClr val="22263A"/>
+            <a:srgbClr val="E5EEFC"/>
           </a:solidFill>
           <a:ln w="5080">
             <a:solidFill>
-              <a:srgbClr val="2E3350"/>
+              <a:srgbClr val="C4D2EB"/>
             </a:solidFill>
           </a:ln>
         </p:spPr>
@@ -9814,7 +9814,7 @@
             <a:r>
               <a:rPr sz="900" b="1" i="0">
                 <a:solidFill>
-                  <a:srgbClr val="FFFFFF"/>
+                  <a:srgbClr val="0F172A"/>
                 </a:solidFill>
               </a:rPr>
               <a:t>FY-28</a:t>
@@ -9837,11 +9837,11 @@
             <a:avLst/>
           </a:prstGeom>
           <a:solidFill>
-            <a:srgbClr val="22263A"/>
+            <a:srgbClr val="E5EEFC"/>
           </a:solidFill>
           <a:ln w="5080">
             <a:solidFill>
-              <a:srgbClr val="2E3350"/>
+              <a:srgbClr val="C4D2EB"/>
             </a:solidFill>
           </a:ln>
         </p:spPr>
@@ -9893,7 +9893,7 @@
             <a:r>
               <a:rPr sz="900" b="0" i="0">
                 <a:solidFill>
-                  <a:srgbClr val="8F96B3"/>
+                  <a:srgbClr val="0F172A"/>
                 </a:solidFill>
               </a:rPr>
               <a:t>—</a:t>
@@ -9916,11 +9916,11 @@
             <a:avLst/>
           </a:prstGeom>
           <a:solidFill>
-            <a:srgbClr val="22263A"/>
+            <a:srgbClr val="E5EEFC"/>
           </a:solidFill>
           <a:ln w="5080">
             <a:solidFill>
-              <a:srgbClr val="2E3350"/>
+              <a:srgbClr val="C4D2EB"/>
             </a:solidFill>
           </a:ln>
         </p:spPr>
@@ -9972,7 +9972,7 @@
             <a:r>
               <a:rPr sz="900" b="0" i="0">
                 <a:solidFill>
-                  <a:srgbClr val="8F96B3"/>
+                  <a:srgbClr val="0F172A"/>
                 </a:solidFill>
               </a:rPr>
               <a:t>$535,591</a:t>
@@ -9995,11 +9995,11 @@
             <a:avLst/>
           </a:prstGeom>
           <a:solidFill>
-            <a:srgbClr val="22263A"/>
+            <a:srgbClr val="E5EEFC"/>
           </a:solidFill>
           <a:ln w="5080">
             <a:solidFill>
-              <a:srgbClr val="2E3350"/>
+              <a:srgbClr val="C4D2EB"/>
             </a:solidFill>
           </a:ln>
         </p:spPr>
@@ -10051,7 +10051,7 @@
             <a:r>
               <a:rPr sz="900" b="0" i="0">
                 <a:solidFill>
-                  <a:srgbClr val="8F96B3"/>
+                  <a:srgbClr val="0F172A"/>
                 </a:solidFill>
               </a:rPr>
               <a:t>—</a:t>
@@ -10074,11 +10074,11 @@
             <a:avLst/>
           </a:prstGeom>
           <a:solidFill>
-            <a:srgbClr val="22263A"/>
+            <a:srgbClr val="E5EEFC"/>
           </a:solidFill>
           <a:ln w="5080">
             <a:solidFill>
-              <a:srgbClr val="2E3350"/>
+              <a:srgbClr val="C4D2EB"/>
             </a:solidFill>
           </a:ln>
         </p:spPr>
@@ -10130,7 +10130,7 @@
             <a:r>
               <a:rPr sz="900" b="0" i="0">
                 <a:solidFill>
-                  <a:srgbClr val="8F96B3"/>
+                  <a:srgbClr val="0F172A"/>
                 </a:solidFill>
               </a:rPr>
               <a:t>$0</a:t>
@@ -10153,11 +10153,11 @@
             <a:avLst/>
           </a:prstGeom>
           <a:solidFill>
-            <a:srgbClr val="22263A"/>
+            <a:srgbClr val="E5EEFC"/>
           </a:solidFill>
           <a:ln w="5080">
             <a:solidFill>
-              <a:srgbClr val="2E3350"/>
+              <a:srgbClr val="C4D2EB"/>
             </a:solidFill>
           </a:ln>
         </p:spPr>
@@ -10209,7 +10209,7 @@
             <a:r>
               <a:rPr sz="900" b="0" i="0">
                 <a:solidFill>
-                  <a:srgbClr val="8F96B3"/>
+                  <a:srgbClr val="0F172A"/>
                 </a:solidFill>
               </a:rPr>
               <a:t>Special</a:t>
@@ -10232,11 +10232,11 @@
             <a:avLst/>
           </a:prstGeom>
           <a:solidFill>
-            <a:srgbClr val="1E3A7A"/>
+            <a:srgbClr val="DBEAFE"/>
           </a:solidFill>
           <a:ln w="5080">
             <a:solidFill>
-              <a:srgbClr val="2E3350"/>
+              <a:srgbClr val="C4D2EB"/>
             </a:solidFill>
           </a:ln>
         </p:spPr>
@@ -10288,7 +10288,7 @@
             <a:r>
               <a:rPr sz="950" b="1" i="0">
                 <a:solidFill>
-                  <a:srgbClr val="FFFFFF"/>
+                  <a:srgbClr val="0F172A"/>
                 </a:solidFill>
               </a:rPr>
               <a:t>TOTAL</a:t>
@@ -10311,11 +10311,11 @@
             <a:avLst/>
           </a:prstGeom>
           <a:solidFill>
-            <a:srgbClr val="1E3A7A"/>
+            <a:srgbClr val="DBEAFE"/>
           </a:solidFill>
           <a:ln w="5080">
             <a:solidFill>
-              <a:srgbClr val="2E3350"/>
+              <a:srgbClr val="C4D2EB"/>
             </a:solidFill>
           </a:ln>
         </p:spPr>
@@ -10367,7 +10367,7 @@
             <a:r>
               <a:rPr sz="950" b="1" i="0">
                 <a:solidFill>
-                  <a:srgbClr val="FFFFFF"/>
+                  <a:srgbClr val="0F172A"/>
                 </a:solidFill>
               </a:rPr>
               <a:t>$6,000,000</a:t>
@@ -10390,11 +10390,11 @@
             <a:avLst/>
           </a:prstGeom>
           <a:solidFill>
-            <a:srgbClr val="1E3A7A"/>
+            <a:srgbClr val="DBEAFE"/>
           </a:solidFill>
           <a:ln w="5080">
             <a:solidFill>
-              <a:srgbClr val="2E3350"/>
+              <a:srgbClr val="C4D2EB"/>
             </a:solidFill>
           </a:ln>
         </p:spPr>
@@ -10446,7 +10446,7 @@
             <a:r>
               <a:rPr sz="950" b="1" i="0">
                 <a:solidFill>
-                  <a:srgbClr val="FFFFFF"/>
+                  <a:srgbClr val="0F172A"/>
                 </a:solidFill>
               </a:rPr>
               <a:t>$3,704,102</a:t>
@@ -10469,11 +10469,11 @@
             <a:avLst/>
           </a:prstGeom>
           <a:solidFill>
-            <a:srgbClr val="1E3A7A"/>
+            <a:srgbClr val="DBEAFE"/>
           </a:solidFill>
           <a:ln w="5080">
             <a:solidFill>
-              <a:srgbClr val="2E3350"/>
+              <a:srgbClr val="C4D2EB"/>
             </a:solidFill>
           </a:ln>
         </p:spPr>
@@ -10525,7 +10525,7 @@
             <a:r>
               <a:rPr sz="950" b="1" i="0">
                 <a:solidFill>
-                  <a:srgbClr val="FFFFFF"/>
+                  <a:srgbClr val="0F172A"/>
                 </a:solidFill>
               </a:rPr>
               <a:t>$1,452,590</a:t>
@@ -10548,11 +10548,11 @@
             <a:avLst/>
           </a:prstGeom>
           <a:solidFill>
-            <a:srgbClr val="1E3A7A"/>
+            <a:srgbClr val="DBEAFE"/>
           </a:solidFill>
           <a:ln w="5080">
             <a:solidFill>
-              <a:srgbClr val="2E3350"/>
+              <a:srgbClr val="C4D2EB"/>
             </a:solidFill>
           </a:ln>
         </p:spPr>
@@ -10604,7 +10604,7 @@
             <a:r>
               <a:rPr sz="950" b="1" i="0">
                 <a:solidFill>
-                  <a:srgbClr val="FFFFFF"/>
+                  <a:srgbClr val="0F172A"/>
                 </a:solidFill>
               </a:rPr>
               <a:t>$1,547,410</a:t>
@@ -10627,11 +10627,11 @@
             <a:avLst/>
           </a:prstGeom>
           <a:solidFill>
-            <a:srgbClr val="1E3A7A"/>
+            <a:srgbClr val="DBEAFE"/>
           </a:solidFill>
           <a:ln w="5080">
             <a:solidFill>
-              <a:srgbClr val="2E3350"/>
+              <a:srgbClr val="C4D2EB"/>
             </a:solidFill>
           </a:ln>
         </p:spPr>
@@ -10683,7 +10683,7 @@
             <a:r>
               <a:rPr sz="950" b="1" i="0">
                 <a:solidFill>
-                  <a:srgbClr val="FFFFFF"/>
+                  <a:srgbClr val="0F172A"/>
                 </a:solidFill>
               </a:rPr>
               <a:t>—</a:t>
@@ -10717,7 +10717,7 @@
             <a:r>
               <a:rPr sz="700" b="1" i="0">
                 <a:solidFill>
-                  <a:srgbClr val="8F96B3"/>
+                  <a:srgbClr val="4A5A82"/>
                 </a:solidFill>
               </a:rPr>
               <a:t>BUDGET UTILIZATION (ACTUAL vs APPROVED)</a:t>
@@ -10751,7 +10751,7 @@
             <a:r>
               <a:rPr sz="900" b="0" i="0">
                 <a:solidFill>
-                  <a:srgbClr val="8F96B3"/>
+                  <a:srgbClr val="4A5A82"/>
                 </a:solidFill>
               </a:rPr>
               <a:t>FY-25</a:t>
@@ -10774,7 +10774,7 @@
             <a:avLst/>
           </a:prstGeom>
           <a:solidFill>
-            <a:srgbClr val="2E3350"/>
+            <a:srgbClr val="C4D2EB"/>
           </a:solidFill>
           <a:ln>
             <a:noFill/>
@@ -10817,7 +10817,7 @@
             <a:avLst/>
           </a:prstGeom>
           <a:solidFill>
-            <a:srgbClr val="22C55E"/>
+            <a:srgbClr val="16803D"/>
           </a:solidFill>
           <a:ln>
             <a:noFill/>
@@ -10871,7 +10871,7 @@
             <a:r>
               <a:rPr sz="900" b="1" i="0">
                 <a:solidFill>
-                  <a:srgbClr val="FFFFFF"/>
+                  <a:srgbClr val="0F172A"/>
                 </a:solidFill>
               </a:rPr>
               <a:t>27.5%</a:t>
@@ -10905,7 +10905,7 @@
             <a:r>
               <a:rPr sz="900" b="0" i="0">
                 <a:solidFill>
-                  <a:srgbClr val="8F96B3"/>
+                  <a:srgbClr val="4A5A82"/>
                 </a:solidFill>
               </a:rPr>
               <a:t>FY-26</a:t>
@@ -10928,7 +10928,7 @@
             <a:avLst/>
           </a:prstGeom>
           <a:solidFill>
-            <a:srgbClr val="2E3350"/>
+            <a:srgbClr val="C4D2EB"/>
           </a:solidFill>
           <a:ln>
             <a:noFill/>
@@ -10971,7 +10971,7 @@
             <a:avLst/>
           </a:prstGeom>
           <a:solidFill>
-            <a:srgbClr val="4F8EF7"/>
+            <a:srgbClr val="2563EB"/>
           </a:solidFill>
           <a:ln>
             <a:noFill/>
@@ -11025,7 +11025,7 @@
             <a:r>
               <a:rPr sz="900" b="1" i="0">
                 <a:solidFill>
-                  <a:srgbClr val="FFFFFF"/>
+                  <a:srgbClr val="0F172A"/>
                 </a:solidFill>
               </a:rPr>
               <a:t>58.9%</a:t>
@@ -11059,7 +11059,7 @@
             <a:r>
               <a:rPr sz="900" b="0" i="0">
                 <a:solidFill>
-                  <a:srgbClr val="8F96B3"/>
+                  <a:srgbClr val="4A5A82"/>
                 </a:solidFill>
               </a:rPr>
               <a:t>FY-27</a:t>
@@ -11082,7 +11082,7 @@
             <a:avLst/>
           </a:prstGeom>
           <a:solidFill>
-            <a:srgbClr val="2E3350"/>
+            <a:srgbClr val="C4D2EB"/>
           </a:solidFill>
           <a:ln>
             <a:noFill/>
@@ -11136,7 +11136,7 @@
             <a:r>
               <a:rPr sz="900" b="1" i="0">
                 <a:solidFill>
-                  <a:srgbClr val="FFFFFF"/>
+                  <a:srgbClr val="0F172A"/>
                 </a:solidFill>
               </a:rPr>
               <a:t>0.0%</a:t>
@@ -11160,7 +11160,7 @@
           </a:prstGeom>
           <a:ln w="6350">
             <a:solidFill>
-              <a:srgbClr val="2E3350"/>
+              <a:srgbClr val="C4D2EB"/>
             </a:solidFill>
           </a:ln>
         </p:spPr>
@@ -11205,7 +11205,7 @@
             <a:r>
               <a:rPr sz="800" b="0" i="0">
                 <a:solidFill>
-                  <a:srgbClr val="8F96B3"/>
+                  <a:srgbClr val="4A5A82"/>
                 </a:solidFill>
               </a:rPr>
               <a:t>PCA: 79103  ·  Object Code: Radiation Control Fund</a:t>
@@ -11227,7 +11227,7 @@
     <p:bg>
       <p:bgPr>
         <a:solidFill>
-          <a:srgbClr val="0F1117"/>
+          <a:srgbClr val="F0F6FF"/>
         </a:solidFill>
         <a:effectLst/>
       </p:bgPr>
@@ -11254,7 +11254,7 @@
             <a:avLst/>
           </a:prstGeom>
           <a:solidFill>
-            <a:srgbClr val="1A1D27"/>
+            <a:srgbClr val="FFFFFF"/>
           </a:solidFill>
           <a:ln>
             <a:noFill/>
@@ -11308,7 +11308,7 @@
             <a:r>
               <a:rPr sz="1600" b="1" i="0">
                 <a:solidFill>
-                  <a:srgbClr val="FFFFFF"/>
+                  <a:srgbClr val="0F172A"/>
                 </a:solidFill>
               </a:rPr>
               <a:t>MVP Capabilities — Groups 3 through 9</a:t>
@@ -11331,11 +11331,11 @@
             <a:avLst/>
           </a:prstGeom>
           <a:solidFill>
-            <a:srgbClr val="1E3A7A"/>
+            <a:srgbClr val="DBEAFE"/>
           </a:solidFill>
           <a:ln w="7620">
             <a:solidFill>
-              <a:srgbClr val="4F8EF7"/>
+              <a:srgbClr val="2563EB"/>
             </a:solidFill>
           </a:ln>
         </p:spPr>
@@ -11376,7 +11376,7 @@
             <a:avLst/>
           </a:prstGeom>
           <a:solidFill>
-            <a:srgbClr val="22263A"/>
+            <a:srgbClr val="E5EEFC"/>
           </a:solidFill>
           <a:ln>
             <a:noFill/>
@@ -11430,7 +11430,7 @@
             <a:r>
               <a:rPr sz="1600" b="0" i="0">
                 <a:solidFill>
-                  <a:srgbClr val="FFFFFF"/>
+                  <a:srgbClr val="0F172A"/>
                 </a:solidFill>
               </a:rPr>
               <a:t>📄</a:t>
@@ -11464,7 +11464,7 @@
             <a:r>
               <a:rPr sz="1100" b="1" i="0">
                 <a:solidFill>
-                  <a:srgbClr val="FFFFFF"/>
+                  <a:srgbClr val="0F172A"/>
                 </a:solidFill>
               </a:rPr>
               <a:t>Portal Submissions</a:t>
@@ -11498,7 +11498,7 @@
             <a:r>
               <a:rPr sz="900" b="0" i="0">
                 <a:solidFill>
-                  <a:srgbClr val="CCD1E8"/>
+                  <a:srgbClr val="4A5A82"/>
                 </a:solidFill>
               </a:rPr>
               <a:t>PDF application submissions through the ESC Portal for Groups 3–9.</a:t>
@@ -11521,11 +11521,11 @@
             <a:avLst/>
           </a:prstGeom>
           <a:solidFill>
-            <a:srgbClr val="165B35"/>
+            <a:srgbClr val="DCFCE7"/>
           </a:solidFill>
           <a:ln w="7620">
             <a:solidFill>
-              <a:srgbClr val="22C55E"/>
+              <a:srgbClr val="16803D"/>
             </a:solidFill>
           </a:ln>
         </p:spPr>
@@ -11566,7 +11566,7 @@
             <a:avLst/>
           </a:prstGeom>
           <a:solidFill>
-            <a:srgbClr val="22263A"/>
+            <a:srgbClr val="E5EEFC"/>
           </a:solidFill>
           <a:ln>
             <a:noFill/>
@@ -11620,7 +11620,7 @@
             <a:r>
               <a:rPr sz="1600" b="0" i="0">
                 <a:solidFill>
-                  <a:srgbClr val="FFFFFF"/>
+                  <a:srgbClr val="0F172A"/>
                 </a:solidFill>
               </a:rPr>
               <a:t>💳</a:t>
@@ -11654,7 +11654,7 @@
             <a:r>
               <a:rPr sz="1100" b="1" i="0">
                 <a:solidFill>
-                  <a:srgbClr val="FFFFFF"/>
+                  <a:srgbClr val="0F172A"/>
                 </a:solidFill>
               </a:rPr>
               <a:t>Electronic Payments</a:t>
@@ -11688,7 +11688,7 @@
             <a:r>
               <a:rPr sz="900" b="0" i="0">
                 <a:solidFill>
-                  <a:srgbClr val="CCD1E8"/>
+                  <a:srgbClr val="4A5A82"/>
                 </a:solidFill>
               </a:rPr>
               <a:t>Credit/debit card and E-check capabilities to immediately resolve clearing delays.</a:t>
@@ -11711,11 +11711,11 @@
             <a:avLst/>
           </a:prstGeom>
           <a:solidFill>
-            <a:srgbClr val="784B05"/>
+            <a:srgbClr val="FEF3C7"/>
           </a:solidFill>
           <a:ln w="7620">
             <a:solidFill>
-              <a:srgbClr val="F59E0B"/>
+              <a:srgbClr val="D97706"/>
             </a:solidFill>
           </a:ln>
         </p:spPr>
@@ -11756,7 +11756,7 @@
             <a:avLst/>
           </a:prstGeom>
           <a:solidFill>
-            <a:srgbClr val="22263A"/>
+            <a:srgbClr val="E5EEFC"/>
           </a:solidFill>
           <a:ln>
             <a:noFill/>
@@ -11810,7 +11810,7 @@
             <a:r>
               <a:rPr sz="1600" b="0" i="0">
                 <a:solidFill>
-                  <a:srgbClr val="FFFFFF"/>
+                  <a:srgbClr val="0F172A"/>
                 </a:solidFill>
               </a:rPr>
               <a:t>🔔</a:t>
@@ -11844,7 +11844,7 @@
             <a:r>
               <a:rPr sz="1100" b="1" i="0">
                 <a:solidFill>
-                  <a:srgbClr val="FFFFFF"/>
+                  <a:srgbClr val="0F172A"/>
                 </a:solidFill>
               </a:rPr>
               <a:t>Notifications</a:t>
@@ -11878,7 +11878,7 @@
             <a:r>
               <a:rPr sz="900" b="0" i="0">
                 <a:solidFill>
-                  <a:srgbClr val="CCD1E8"/>
+                  <a:srgbClr val="4A5A82"/>
                 </a:solidFill>
               </a:rPr>
               <a:t>One-time email confirmations for end-users upon application and payment submission.</a:t>
@@ -11901,11 +11901,11 @@
             <a:avLst/>
           </a:prstGeom>
           <a:solidFill>
-            <a:srgbClr val="3A1560"/>
+            <a:srgbClr val="EDE9FE"/>
           </a:solidFill>
           <a:ln w="7620">
             <a:solidFill>
-              <a:srgbClr val="A855F7"/>
+              <a:srgbClr val="6D28D9"/>
             </a:solidFill>
           </a:ln>
         </p:spPr>
@@ -11946,7 +11946,7 @@
             <a:avLst/>
           </a:prstGeom>
           <a:solidFill>
-            <a:srgbClr val="22263A"/>
+            <a:srgbClr val="E5EEFC"/>
           </a:solidFill>
           <a:ln>
             <a:noFill/>
@@ -12000,7 +12000,7 @@
             <a:r>
               <a:rPr sz="1600" b="0" i="0">
                 <a:solidFill>
-                  <a:srgbClr val="FFFFFF"/>
+                  <a:srgbClr val="0F172A"/>
                 </a:solidFill>
               </a:rPr>
               <a:t>📥</a:t>
@@ -12034,7 +12034,7 @@
             <a:r>
               <a:rPr sz="1100" b="1" i="0">
                 <a:solidFill>
-                  <a:srgbClr val="FFFFFF"/>
+                  <a:srgbClr val="0F172A"/>
                 </a:solidFill>
               </a:rPr>
               <a:t>RHP Team Inbox</a:t>
@@ -12068,7 +12068,7 @@
             <a:r>
               <a:rPr sz="900" b="0" i="0">
                 <a:solidFill>
-                  <a:srgbClr val="CCD1E8"/>
+                  <a:srgbClr val="4A5A82"/>
                 </a:solidFill>
               </a:rPr>
               <a:t>Automated notifications delivered to the MDE Business User (RHP Team) inbox.</a:t>
@@ -12091,11 +12091,11 @@
             <a:avLst/>
           </a:prstGeom>
           <a:solidFill>
-            <a:srgbClr val="703015"/>
+            <a:srgbClr val="FFEDD5"/>
           </a:solidFill>
           <a:ln w="7620">
             <a:solidFill>
-              <a:srgbClr val="FF7F50"/>
+              <a:srgbClr val="C2410C"/>
             </a:solidFill>
           </a:ln>
         </p:spPr>
@@ -12136,7 +12136,7 @@
             <a:avLst/>
           </a:prstGeom>
           <a:solidFill>
-            <a:srgbClr val="22263A"/>
+            <a:srgbClr val="E5EEFC"/>
           </a:solidFill>
           <a:ln>
             <a:noFill/>
@@ -12190,7 +12190,7 @@
             <a:r>
               <a:rPr sz="1600" b="0" i="0">
                 <a:solidFill>
-                  <a:srgbClr val="FFFFFF"/>
+                  <a:srgbClr val="0F172A"/>
                 </a:solidFill>
               </a:rPr>
               <a:t>📁</a:t>
@@ -12224,7 +12224,7 @@
             <a:r>
               <a:rPr sz="1100" b="1" i="0">
                 <a:solidFill>
-                  <a:srgbClr val="FFFFFF"/>
+                  <a:srgbClr val="0F172A"/>
                 </a:solidFill>
               </a:rPr>
               <a:t>Document Management</a:t>
@@ -12258,7 +12258,7 @@
             <a:r>
               <a:rPr sz="900" b="0" i="0">
                 <a:solidFill>
-                  <a:srgbClr val="CCD1E8"/>
+                  <a:srgbClr val="4A5A82"/>
                 </a:solidFill>
               </a:rPr>
               <a:t>Secure view, download of applications and supporting documents — individual files or ZIP.</a:t>
@@ -12281,11 +12281,11 @@
             <a:avLst/>
           </a:prstGeom>
           <a:solidFill>
-            <a:srgbClr val="074555"/>
+            <a:srgbClr val="CCF0F8"/>
           </a:solidFill>
           <a:ln w="7620">
             <a:solidFill>
-              <a:srgbClr val="06B6D4"/>
+              <a:srgbClr val="0891B2"/>
             </a:solidFill>
           </a:ln>
         </p:spPr>
@@ -12326,7 +12326,7 @@
             <a:avLst/>
           </a:prstGeom>
           <a:solidFill>
-            <a:srgbClr val="22263A"/>
+            <a:srgbClr val="E5EEFC"/>
           </a:solidFill>
           <a:ln>
             <a:noFill/>
@@ -12380,7 +12380,7 @@
             <a:r>
               <a:rPr sz="1600" b="0" i="0">
                 <a:solidFill>
-                  <a:srgbClr val="FFFFFF"/>
+                  <a:srgbClr val="0F172A"/>
                 </a:solidFill>
               </a:rPr>
               <a:t>🔐</a:t>
@@ -12414,7 +12414,7 @@
             <a:r>
               <a:rPr sz="1100" b="1" i="0">
                 <a:solidFill>
-                  <a:srgbClr val="FFFFFF"/>
+                  <a:srgbClr val="0F172A"/>
                 </a:solidFill>
               </a:rPr>
               <a:t>IAM Authentication</a:t>
@@ -12448,7 +12448,7 @@
             <a:r>
               <a:rPr sz="900" b="0" i="0">
                 <a:solidFill>
-                  <a:srgbClr val="CCD1E8"/>
+                  <a:srgbClr val="4A5A82"/>
                 </a:solidFill>
               </a:rPr>
               <a:t>MDE Business User authentication via Identity and Access Management (IAM) protocols.</a:t>
@@ -12472,7 +12472,7 @@
           </a:prstGeom>
           <a:ln w="6350">
             <a:solidFill>
-              <a:srgbClr val="2E3350"/>
+              <a:srgbClr val="C4D2EB"/>
             </a:solidFill>
           </a:ln>
         </p:spPr>
@@ -12517,7 +12517,7 @@
             <a:r>
               <a:rPr sz="800" b="0" i="0">
                 <a:solidFill>
-                  <a:srgbClr val="8F96B3"/>
+                  <a:srgbClr val="4A5A82"/>
                 </a:solidFill>
               </a:rPr>
               <a:t>Groups 1–2 configuration and setup planned in Sprint 5</a:t>
@@ -12539,7 +12539,7 @@
     <p:bg>
       <p:bgPr>
         <a:solidFill>
-          <a:srgbClr val="0F1117"/>
+          <a:srgbClr val="F0F6FF"/>
         </a:solidFill>
         <a:effectLst/>
       </p:bgPr>
@@ -12566,7 +12566,7 @@
             <a:avLst/>
           </a:prstGeom>
           <a:solidFill>
-            <a:srgbClr val="1A1D27"/>
+            <a:srgbClr val="FFFFFF"/>
           </a:solidFill>
           <a:ln>
             <a:noFill/>
@@ -12620,7 +12620,7 @@
             <a:r>
               <a:rPr sz="1600" b="1" i="0">
                 <a:solidFill>
-                  <a:srgbClr val="FFFFFF"/>
+                  <a:srgbClr val="0F172A"/>
                 </a:solidFill>
               </a:rPr>
               <a:t>Risks, Impediments &amp; Action Items</a:t>
@@ -12654,7 +12654,7 @@
             <a:r>
               <a:rPr sz="750" b="1" i="0">
                 <a:solidFill>
-                  <a:srgbClr val="8F96B3"/>
+                  <a:srgbClr val="4A5A82"/>
                 </a:solidFill>
               </a:rPr>
               <a:t>ACTIVE RISKS &amp; IMPEDIMENTS</a:t>
@@ -12677,11 +12677,11 @@
             <a:avLst/>
           </a:prstGeom>
           <a:solidFill>
-            <a:srgbClr val="7A1D1D"/>
+            <a:srgbClr val="FEE2E2"/>
           </a:solidFill>
           <a:ln w="9525">
             <a:solidFill>
-              <a:srgbClr val="EF4444"/>
+              <a:srgbClr val="DC2626"/>
             </a:solidFill>
           </a:ln>
         </p:spPr>
@@ -12722,7 +12722,7 @@
             <a:avLst/>
           </a:prstGeom>
           <a:solidFill>
-            <a:srgbClr val="EF4444"/>
+            <a:srgbClr val="DC2626"/>
           </a:solidFill>
           <a:ln>
             <a:noFill/>
@@ -12776,7 +12776,7 @@
             <a:r>
               <a:rPr sz="750" b="1" i="0">
                 <a:solidFill>
-                  <a:srgbClr val="0F1117"/>
+                  <a:srgbClr val="FFFFFF"/>
                 </a:solidFill>
               </a:rPr>
               <a:t>HIGH</a:t>
@@ -12810,7 +12810,7 @@
             <a:r>
               <a:rPr sz="1050" b="1" i="0">
                 <a:solidFill>
-                  <a:srgbClr val="FFFFFF"/>
+                  <a:srgbClr val="0F172A"/>
                 </a:solidFill>
               </a:rPr>
               <a:t>Environment &amp; Build Issues</a:t>
@@ -12844,7 +12844,7 @@
             <a:r>
               <a:rPr sz="850" b="0" i="0">
                 <a:solidFill>
-                  <a:srgbClr val="CCD1E8"/>
+                  <a:srgbClr val="4A5A82"/>
                 </a:solidFill>
               </a:rPr>
               <a:t>Encountered environment and build issues impacting iterative delivery. Development and validation processes are established and being monitored. Mitigation: Hiring a Tech Lead to address future environmental/build blockers.</a:t>
@@ -12867,11 +12867,11 @@
             <a:avLst/>
           </a:prstGeom>
           <a:solidFill>
-            <a:srgbClr val="1A1D27"/>
+            <a:srgbClr val="FFFFFF"/>
           </a:solidFill>
           <a:ln w="9525">
             <a:solidFill>
-              <a:srgbClr val="2E3350"/>
+              <a:srgbClr val="C4D2EB"/>
             </a:solidFill>
           </a:ln>
         </p:spPr>
@@ -12923,7 +12923,7 @@
             <a:r>
               <a:rPr sz="700" b="1" i="0">
                 <a:solidFill>
-                  <a:srgbClr val="8F96B3"/>
+                  <a:srgbClr val="4A5A82"/>
                 </a:solidFill>
               </a:rPr>
               <a:t>RESPONSE STRATEGY</a:t>
@@ -12957,7 +12957,7 @@
             <a:r>
               <a:rPr sz="1300" b="1" i="0">
                 <a:solidFill>
-                  <a:srgbClr val="EF4444"/>
+                  <a:srgbClr val="DC2626"/>
                 </a:solidFill>
               </a:rPr>
               <a:t>Mitigate</a:t>
@@ -12980,11 +12980,11 @@
             <a:avLst/>
           </a:prstGeom>
           <a:solidFill>
-            <a:srgbClr val="784B05"/>
+            <a:srgbClr val="FEF3C7"/>
           </a:solidFill>
           <a:ln w="9525">
             <a:solidFill>
-              <a:srgbClr val="F59E0B"/>
+              <a:srgbClr val="D97706"/>
             </a:solidFill>
           </a:ln>
         </p:spPr>
@@ -13025,7 +13025,7 @@
             <a:avLst/>
           </a:prstGeom>
           <a:solidFill>
-            <a:srgbClr val="F59E0B"/>
+            <a:srgbClr val="D97706"/>
           </a:solidFill>
           <a:ln>
             <a:noFill/>
@@ -13079,7 +13079,7 @@
             <a:r>
               <a:rPr sz="750" b="1" i="0">
                 <a:solidFill>
-                  <a:srgbClr val="0F1117"/>
+                  <a:srgbClr val="FFFFFF"/>
                 </a:solidFill>
               </a:rPr>
               <a:t>MEDIUM</a:t>
@@ -13113,7 +13113,7 @@
             <a:r>
               <a:rPr sz="1050" b="1" i="0">
                 <a:solidFill>
-                  <a:srgbClr val="FFFFFF"/>
+                  <a:srgbClr val="0F172A"/>
                 </a:solidFill>
               </a:rPr>
               <a:t>Workflow Finalization</a:t>
@@ -13147,7 +13147,7 @@
             <a:r>
               <a:rPr sz="850" b="0" i="0">
                 <a:solidFill>
-                  <a:srgbClr val="CCD1E8"/>
+                  <a:srgbClr val="4A5A82"/>
                 </a:solidFill>
               </a:rPr>
               <a:t>Non-ETS workflow approach requires finalization: future status tracking, Third-Party access (Inspectors), Liability Checks, and invoice payment features. DoIT &amp; MDE teams reviewing enterprise solutions.</a:t>
@@ -13170,11 +13170,11 @@
             <a:avLst/>
           </a:prstGeom>
           <a:solidFill>
-            <a:srgbClr val="1A1D27"/>
+            <a:srgbClr val="FFFFFF"/>
           </a:solidFill>
           <a:ln w="9525">
             <a:solidFill>
-              <a:srgbClr val="2E3350"/>
+              <a:srgbClr val="C4D2EB"/>
             </a:solidFill>
           </a:ln>
         </p:spPr>
@@ -13226,7 +13226,7 @@
             <a:r>
               <a:rPr sz="700" b="1" i="0">
                 <a:solidFill>
-                  <a:srgbClr val="8F96B3"/>
+                  <a:srgbClr val="4A5A82"/>
                 </a:solidFill>
               </a:rPr>
               <a:t>RESPONSE STRATEGY</a:t>
@@ -13260,7 +13260,7 @@
             <a:r>
               <a:rPr sz="1300" b="1" i="0">
                 <a:solidFill>
-                  <a:srgbClr val="F59E0B"/>
+                  <a:srgbClr val="D97706"/>
                 </a:solidFill>
               </a:rPr>
               <a:t>Transfer</a:t>
@@ -13283,11 +13283,11 @@
             <a:avLst/>
           </a:prstGeom>
           <a:solidFill>
-            <a:srgbClr val="784B05"/>
+            <a:srgbClr val="FEF3C7"/>
           </a:solidFill>
           <a:ln w="9525">
             <a:solidFill>
-              <a:srgbClr val="F59E0B"/>
+              <a:srgbClr val="D97706"/>
             </a:solidFill>
           </a:ln>
         </p:spPr>
@@ -13328,7 +13328,7 @@
             <a:avLst/>
           </a:prstGeom>
           <a:solidFill>
-            <a:srgbClr val="F59E0B"/>
+            <a:srgbClr val="D97706"/>
           </a:solidFill>
           <a:ln>
             <a:noFill/>
@@ -13382,7 +13382,7 @@
             <a:r>
               <a:rPr sz="750" b="1" i="0">
                 <a:solidFill>
-                  <a:srgbClr val="0F1117"/>
+                  <a:srgbClr val="FFFFFF"/>
                 </a:solidFill>
               </a:rPr>
               <a:t>MEDIUM</a:t>
@@ -13416,7 +13416,7 @@
             <a:r>
               <a:rPr sz="1050" b="1" i="0">
                 <a:solidFill>
-                  <a:srgbClr val="FFFFFF"/>
+                  <a:srgbClr val="0F172A"/>
                 </a:solidFill>
               </a:rPr>
               <a:t>Registration Number Automation</a:t>
@@ -13450,7 +13450,7 @@
             <a:r>
               <a:rPr sz="850" b="0" i="0">
                 <a:solidFill>
-                  <a:srgbClr val="CCD1E8"/>
+                  <a:srgbClr val="4A5A82"/>
                 </a:solidFill>
               </a:rPr>
               <a:t>Program must decide on folder naming convention and whether the system auto-generates sequence numbers as part of modernization, or continues the current manual process. Awaiting program decision.</a:t>
@@ -13473,11 +13473,11 @@
             <a:avLst/>
           </a:prstGeom>
           <a:solidFill>
-            <a:srgbClr val="1A1D27"/>
+            <a:srgbClr val="FFFFFF"/>
           </a:solidFill>
           <a:ln w="9525">
             <a:solidFill>
-              <a:srgbClr val="2E3350"/>
+              <a:srgbClr val="C4D2EB"/>
             </a:solidFill>
           </a:ln>
         </p:spPr>
@@ -13529,7 +13529,7 @@
             <a:r>
               <a:rPr sz="700" b="1" i="0">
                 <a:solidFill>
-                  <a:srgbClr val="8F96B3"/>
+                  <a:srgbClr val="4A5A82"/>
                 </a:solidFill>
               </a:rPr>
               <a:t>RESPONSE STRATEGY</a:t>
@@ -13563,7 +13563,7 @@
             <a:r>
               <a:rPr sz="1300" b="1" i="0">
                 <a:solidFill>
-                  <a:srgbClr val="F59E0B"/>
+                  <a:srgbClr val="D97706"/>
                 </a:solidFill>
               </a:rPr>
               <a:t>Mitigate</a:t>
@@ -13597,7 +13597,7 @@
             <a:r>
               <a:rPr sz="750" b="1" i="0">
                 <a:solidFill>
-                  <a:srgbClr val="8F96B3"/>
+                  <a:srgbClr val="4A5A82"/>
                 </a:solidFill>
               </a:rPr>
               <a:t>ACTION ITEMS</a:t>
@@ -13620,11 +13620,11 @@
             <a:avLst/>
           </a:prstGeom>
           <a:solidFill>
-            <a:srgbClr val="1A1D27"/>
+            <a:srgbClr val="FFFFFF"/>
           </a:solidFill>
           <a:ln w="9525">
             <a:solidFill>
-              <a:srgbClr val="2E3350"/>
+              <a:srgbClr val="C4D2EB"/>
             </a:solidFill>
           </a:ln>
         </p:spPr>
@@ -13665,7 +13665,7 @@
             <a:avLst/>
           </a:prstGeom>
           <a:solidFill>
-            <a:srgbClr val="4F8EF7"/>
+            <a:srgbClr val="2563EB"/>
           </a:solidFill>
           <a:ln>
             <a:noFill/>
@@ -13719,7 +13719,7 @@
             <a:r>
               <a:rPr sz="1000" b="1" i="0">
                 <a:solidFill>
-                  <a:srgbClr val="FFFFFF"/>
+                  <a:srgbClr val="0F172A"/>
                 </a:solidFill>
               </a:rPr>
               <a:t>MVP Time Savings</a:t>
@@ -13753,7 +13753,7 @@
             <a:r>
               <a:rPr sz="850" b="0" i="0">
                 <a:solidFill>
-                  <a:srgbClr val="8F96B3"/>
+                  <a:srgbClr val="4A5A82"/>
                 </a:solidFill>
               </a:rPr>
               <a:t>Collaborate with program team to generate high-level estimates of days saved per MVP deliverable (80/20 rule).</a:t>
@@ -13776,11 +13776,11 @@
             <a:avLst/>
           </a:prstGeom>
           <a:solidFill>
-            <a:srgbClr val="1A1D27"/>
+            <a:srgbClr val="FFFFFF"/>
           </a:solidFill>
           <a:ln w="9525">
             <a:solidFill>
-              <a:srgbClr val="2E3350"/>
+              <a:srgbClr val="C4D2EB"/>
             </a:solidFill>
           </a:ln>
         </p:spPr>
@@ -13821,7 +13821,7 @@
             <a:avLst/>
           </a:prstGeom>
           <a:solidFill>
-            <a:srgbClr val="F59E0B"/>
+            <a:srgbClr val="D97706"/>
           </a:solidFill>
           <a:ln>
             <a:noFill/>
@@ -13875,7 +13875,7 @@
             <a:r>
               <a:rPr sz="1000" b="1" i="0">
                 <a:solidFill>
-                  <a:srgbClr val="FFFFFF"/>
+                  <a:srgbClr val="0F172A"/>
                 </a:solidFill>
               </a:rPr>
               <a:t>Liability Check</a:t>
@@ -13909,7 +13909,7 @@
             <a:r>
               <a:rPr sz="850" b="0" i="0">
                 <a:solidFill>
-                  <a:srgbClr val="8F96B3"/>
+                  <a:srgbClr val="4A5A82"/>
                 </a:solidFill>
               </a:rPr>
               <a:t>Remain closely coordinated with Emil, Paul, and the DoIT team while awaiting update from State Data Officer.</a:t>
@@ -13932,11 +13932,11 @@
             <a:avLst/>
           </a:prstGeom>
           <a:solidFill>
-            <a:srgbClr val="1A1D27"/>
+            <a:srgbClr val="FFFFFF"/>
           </a:solidFill>
           <a:ln w="9525">
             <a:solidFill>
-              <a:srgbClr val="2E3350"/>
+              <a:srgbClr val="C4D2EB"/>
             </a:solidFill>
           </a:ln>
         </p:spPr>
@@ -13977,7 +13977,7 @@
             <a:avLst/>
           </a:prstGeom>
           <a:solidFill>
-            <a:srgbClr val="22C55E"/>
+            <a:srgbClr val="16803D"/>
           </a:solidFill>
           <a:ln>
             <a:noFill/>
@@ -14031,7 +14031,7 @@
             <a:r>
               <a:rPr sz="1000" b="1" i="0">
                 <a:solidFill>
-                  <a:srgbClr val="FFFFFF"/>
+                  <a:srgbClr val="0F172A"/>
                 </a:solidFill>
               </a:rPr>
               <a:t>User Testing</a:t>
@@ -14065,7 +14065,7 @@
             <a:r>
               <a:rPr sz="850" b="0" i="0">
                 <a:solidFill>
-                  <a:srgbClr val="8F96B3"/>
+                  <a:srgbClr val="4A5A82"/>
                 </a:solidFill>
               </a:rPr>
               <a:t>Align with Paul to ensure user testing is seamlessly integrated into development cycles.</a:t>
@@ -14089,7 +14089,7 @@
           </a:prstGeom>
           <a:ln w="6350">
             <a:solidFill>
-              <a:srgbClr val="2E3350"/>
+              <a:srgbClr val="C4D2EB"/>
             </a:solidFill>
           </a:ln>
         </p:spPr>
@@ -14134,7 +14134,7 @@
             <a:r>
               <a:rPr sz="800" b="0" i="0">
                 <a:solidFill>
-                  <a:srgbClr val="8F96B3"/>
+                  <a:srgbClr val="4A5A82"/>
                 </a:solidFill>
               </a:rPr>
               <a:t>Risk Strategy: Mitigate = internal action  ·  Transfer = escalate / partner</a:t>
@@ -14156,7 +14156,7 @@
     <p:bg>
       <p:bgPr>
         <a:solidFill>
-          <a:srgbClr val="0F1117"/>
+          <a:srgbClr val="F0F6FF"/>
         </a:solidFill>
         <a:effectLst/>
       </p:bgPr>
@@ -14183,7 +14183,7 @@
             <a:avLst/>
           </a:prstGeom>
           <a:solidFill>
-            <a:srgbClr val="1A1D27"/>
+            <a:srgbClr val="FFFFFF"/>
           </a:solidFill>
           <a:ln>
             <a:noFill/>
@@ -14237,7 +14237,7 @@
             <a:r>
               <a:rPr sz="1600" b="1" i="0">
                 <a:solidFill>
-                  <a:srgbClr val="FFFFFF"/>
+                  <a:srgbClr val="0F172A"/>
                 </a:solidFill>
               </a:rPr>
               <a:t>Successes &amp; Key Progress — Reporting Period</a:t>
@@ -14260,11 +14260,11 @@
             <a:avLst/>
           </a:prstGeom>
           <a:solidFill>
-            <a:srgbClr val="1A1D27"/>
+            <a:srgbClr val="FFFFFF"/>
           </a:solidFill>
           <a:ln w="9525">
             <a:solidFill>
-              <a:srgbClr val="2E3350"/>
+              <a:srgbClr val="C4D2EB"/>
             </a:solidFill>
           </a:ln>
         </p:spPr>
@@ -14305,7 +14305,7 @@
             <a:avLst/>
           </a:prstGeom>
           <a:solidFill>
-            <a:srgbClr val="22C55E"/>
+            <a:srgbClr val="16803D"/>
           </a:solidFill>
           <a:ln>
             <a:noFill/>
@@ -14359,7 +14359,7 @@
             <a:r>
               <a:rPr sz="2600" b="0" i="0">
                 <a:solidFill>
-                  <a:srgbClr val="FFFFFF"/>
+                  <a:srgbClr val="0F172A"/>
                 </a:solidFill>
               </a:rPr>
               <a:t>✅</a:t>
@@ -14393,7 +14393,7 @@
             <a:r>
               <a:rPr sz="1300" b="1" i="0">
                 <a:solidFill>
-                  <a:srgbClr val="FFFFFF"/>
+                  <a:srgbClr val="0F172A"/>
                 </a:solidFill>
               </a:rPr>
               <a:t>MVP Release Development</a:t>
@@ -14427,7 +14427,7 @@
             <a:r>
               <a:rPr sz="950" b="0" i="0">
                 <a:solidFill>
-                  <a:srgbClr val="CCD1E8"/>
+                  <a:srgbClr val="4A5A82"/>
                 </a:solidFill>
               </a:rPr>
               <a:t>The team is actively working on the MVP release supporting New Applications for Groups 3 through 9. Re-certification and Renewal workflows are under review pending Liability Check clarification (Certificate of Good Standing — new system does not require Tax ID or SSN).</a:t>
@@ -14450,11 +14450,11 @@
             <a:avLst/>
           </a:prstGeom>
           <a:solidFill>
-            <a:srgbClr val="1A1D27"/>
+            <a:srgbClr val="FFFFFF"/>
           </a:solidFill>
           <a:ln w="9525">
             <a:solidFill>
-              <a:srgbClr val="2E3350"/>
+              <a:srgbClr val="C4D2EB"/>
             </a:solidFill>
           </a:ln>
         </p:spPr>
@@ -14495,7 +14495,7 @@
             <a:avLst/>
           </a:prstGeom>
           <a:solidFill>
-            <a:srgbClr val="4F8EF7"/>
+            <a:srgbClr val="2563EB"/>
           </a:solidFill>
           <a:ln>
             <a:noFill/>
@@ -14549,7 +14549,7 @@
             <a:r>
               <a:rPr sz="2600" b="0" i="0">
                 <a:solidFill>
-                  <a:srgbClr val="FFFFFF"/>
+                  <a:srgbClr val="0F172A"/>
                 </a:solidFill>
               </a:rPr>
               <a:t>⚙️</a:t>
@@ -14583,7 +14583,7 @@
             <a:r>
               <a:rPr sz="1300" b="1" i="0">
                 <a:solidFill>
-                  <a:srgbClr val="FFFFFF"/>
+                  <a:srgbClr val="0F172A"/>
                 </a:solidFill>
               </a:rPr>
               <a:t>ESC Page Validations &amp; Verification</a:t>
@@ -14617,7 +14617,7 @@
             <a:r>
               <a:rPr sz="950" b="0" i="0">
                 <a:solidFill>
-                  <a:srgbClr val="CCD1E8"/>
+                  <a:srgbClr val="4A5A82"/>
                 </a:solidFill>
               </a:rPr>
               <a:t>The RHP Team is developing the RHP Configuration Template to govern ESC Portal page validations, ensuring data integrity and compliance across all application submissions.</a:t>
@@ -14640,11 +14640,11 @@
             <a:avLst/>
           </a:prstGeom>
           <a:solidFill>
-            <a:srgbClr val="1A1D27"/>
+            <a:srgbClr val="FFFFFF"/>
           </a:solidFill>
           <a:ln w="9525">
             <a:solidFill>
-              <a:srgbClr val="2E3350"/>
+              <a:srgbClr val="C4D2EB"/>
             </a:solidFill>
           </a:ln>
         </p:spPr>
@@ -14685,7 +14685,7 @@
             <a:avLst/>
           </a:prstGeom>
           <a:solidFill>
-            <a:srgbClr val="A855F7"/>
+            <a:srgbClr val="6D28D9"/>
           </a:solidFill>
           <a:ln>
             <a:noFill/>
@@ -14739,7 +14739,7 @@
             <a:r>
               <a:rPr sz="2600" b="0" i="0">
                 <a:solidFill>
-                  <a:srgbClr val="FFFFFF"/>
+                  <a:srgbClr val="0F172A"/>
                 </a:solidFill>
               </a:rPr>
               <a:t>🔐</a:t>
@@ -14773,7 +14773,7 @@
             <a:r>
               <a:rPr sz="1300" b="1" i="0">
                 <a:solidFill>
-                  <a:srgbClr val="FFFFFF"/>
+                  <a:srgbClr val="0F172A"/>
                 </a:solidFill>
               </a:rPr>
               <a:t>Authentication &amp; Database Restructuring</a:t>
@@ -14807,7 +14807,7 @@
             <a:r>
               <a:rPr sz="950" b="0" i="0">
                 <a:solidFill>
-                  <a:srgbClr val="CCD1E8"/>
+                  <a:srgbClr val="4A5A82"/>
                 </a:solidFill>
               </a:rPr>
               <a:t>Work has commenced on MDE Business User authentication using Identity and Access Management (IAM) protocols, alongside the necessary restructuring of legacy RHP applications and database tables to support modern workflows.</a:t>
@@ -14831,7 +14831,7 @@
           </a:prstGeom>
           <a:ln w="6350">
             <a:solidFill>
-              <a:srgbClr val="2E3350"/>
+              <a:srgbClr val="C4D2EB"/>
             </a:solidFill>
           </a:ln>
         </p:spPr>
@@ -14876,7 +14876,7 @@
             <a:r>
               <a:rPr sz="800" b="0" i="0">
                 <a:solidFill>
-                  <a:srgbClr val="8F96B3"/>
+                  <a:srgbClr val="4A5A82"/>
                 </a:solidFill>
               </a:rPr>
               <a:t>Sprint 1 completed successfully  ·  Sprint 2 currently in progress (Jul 1–14, 2026)</a:t>
@@ -14898,7 +14898,7 @@
     <p:bg>
       <p:bgPr>
         <a:solidFill>
-          <a:srgbClr val="0F1117"/>
+          <a:srgbClr val="F0F6FF"/>
         </a:solidFill>
         <a:effectLst/>
       </p:bgPr>
@@ -14925,7 +14925,7 @@
             <a:avLst/>
           </a:prstGeom>
           <a:solidFill>
-            <a:srgbClr val="1A1D27"/>
+            <a:srgbClr val="FFFFFF"/>
           </a:solidFill>
           <a:ln>
             <a:noFill/>
@@ -14979,7 +14979,7 @@
             <a:r>
               <a:rPr sz="1600" b="1" i="0">
                 <a:solidFill>
-                  <a:srgbClr val="FFFFFF"/>
+                  <a:srgbClr val="0F172A"/>
                 </a:solidFill>
               </a:rPr>
               <a:t>Executive Summary &amp; Next Steps</a:t>
@@ -15002,11 +15002,11 @@
             <a:avLst/>
           </a:prstGeom>
           <a:solidFill>
-            <a:srgbClr val="784B05"/>
+            <a:srgbClr val="FEF3C7"/>
           </a:solidFill>
           <a:ln w="9525">
             <a:solidFill>
-              <a:srgbClr val="F59E0B"/>
+              <a:srgbClr val="D97706"/>
             </a:solidFill>
           </a:ln>
         </p:spPr>
@@ -15058,7 +15058,7 @@
             <a:r>
               <a:rPr sz="750" b="1" i="0">
                 <a:solidFill>
-                  <a:srgbClr val="8F96B3"/>
+                  <a:srgbClr val="4A5A82"/>
                 </a:solidFill>
               </a:rPr>
               <a:t>Overall</a:t>
@@ -15092,7 +15092,7 @@
             <a:r>
               <a:rPr sz="1600" b="1" i="0">
                 <a:solidFill>
-                  <a:srgbClr val="F59E0B"/>
+                  <a:srgbClr val="D97706"/>
                 </a:solidFill>
               </a:rPr>
               <a:t>YELLOW</a:t>
@@ -15115,11 +15115,11 @@
             <a:avLst/>
           </a:prstGeom>
           <a:solidFill>
-            <a:srgbClr val="165B35"/>
+            <a:srgbClr val="DCFCE7"/>
           </a:solidFill>
           <a:ln w="9525">
             <a:solidFill>
-              <a:srgbClr val="22C55E"/>
+              <a:srgbClr val="16803D"/>
             </a:solidFill>
           </a:ln>
         </p:spPr>
@@ -15171,7 +15171,7 @@
             <a:r>
               <a:rPr sz="750" b="1" i="0">
                 <a:solidFill>
-                  <a:srgbClr val="8F96B3"/>
+                  <a:srgbClr val="4A5A82"/>
                 </a:solidFill>
               </a:rPr>
               <a:t>Schedule</a:t>
@@ -15205,7 +15205,7 @@
             <a:r>
               <a:rPr sz="1600" b="1" i="0">
                 <a:solidFill>
-                  <a:srgbClr val="22C55E"/>
+                  <a:srgbClr val="16803D"/>
                 </a:solidFill>
               </a:rPr>
               <a:t>ON TRACK</a:t>
@@ -15228,11 +15228,11 @@
             <a:avLst/>
           </a:prstGeom>
           <a:solidFill>
-            <a:srgbClr val="165B35"/>
+            <a:srgbClr val="DCFCE7"/>
           </a:solidFill>
           <a:ln w="9525">
             <a:solidFill>
-              <a:srgbClr val="22C55E"/>
+              <a:srgbClr val="16803D"/>
             </a:solidFill>
           </a:ln>
         </p:spPr>
@@ -15284,7 +15284,7 @@
             <a:r>
               <a:rPr sz="750" b="1" i="0">
                 <a:solidFill>
-                  <a:srgbClr val="8F96B3"/>
+                  <a:srgbClr val="4A5A82"/>
                 </a:solidFill>
               </a:rPr>
               <a:t>Cost</a:t>
@@ -15318,7 +15318,7 @@
             <a:r>
               <a:rPr sz="1600" b="1" i="0">
                 <a:solidFill>
-                  <a:srgbClr val="22C55E"/>
+                  <a:srgbClr val="16803D"/>
                 </a:solidFill>
               </a:rPr>
               <a:t>ON TRACK</a:t>
@@ -15341,11 +15341,11 @@
             <a:avLst/>
           </a:prstGeom>
           <a:solidFill>
-            <a:srgbClr val="1E3A7A"/>
+            <a:srgbClr val="DBEAFE"/>
           </a:solidFill>
           <a:ln w="9525">
             <a:solidFill>
-              <a:srgbClr val="4F8EF7"/>
+              <a:srgbClr val="2563EB"/>
             </a:solidFill>
           </a:ln>
         </p:spPr>
@@ -15397,7 +15397,7 @@
             <a:r>
               <a:rPr sz="750" b="1" i="0">
                 <a:solidFill>
-                  <a:srgbClr val="8F96B3"/>
+                  <a:srgbClr val="4A5A82"/>
                 </a:solidFill>
               </a:rPr>
               <a:t>Delivery</a:t>
@@ -15431,7 +15431,7 @@
             <a:r>
               <a:rPr sz="1600" b="1" i="0">
                 <a:solidFill>
-                  <a:srgbClr val="4F8EF7"/>
+                  <a:srgbClr val="2563EB"/>
                 </a:solidFill>
               </a:rPr>
               <a:t>MVP Q3</a:t>
@@ -15465,7 +15465,7 @@
             <a:r>
               <a:rPr sz="750" b="1" i="0">
                 <a:solidFill>
-                  <a:srgbClr val="8F96B3"/>
+                  <a:srgbClr val="4A5A82"/>
                 </a:solidFill>
               </a:rPr>
               <a:t>KEY TAKEAWAYS</a:t>
@@ -15488,11 +15488,11 @@
             <a:avLst/>
           </a:prstGeom>
           <a:solidFill>
-            <a:srgbClr val="1A1D27"/>
+            <a:srgbClr val="FFFFFF"/>
           </a:solidFill>
           <a:ln w="9525">
             <a:solidFill>
-              <a:srgbClr val="2E3350"/>
+              <a:srgbClr val="C4D2EB"/>
             </a:solidFill>
           </a:ln>
         </p:spPr>
@@ -15533,7 +15533,7 @@
             <a:avLst/>
           </a:prstGeom>
           <a:solidFill>
-            <a:srgbClr val="22C55E"/>
+            <a:srgbClr val="16803D"/>
           </a:solidFill>
           <a:ln>
             <a:noFill/>
@@ -15587,7 +15587,7 @@
             <a:r>
               <a:rPr sz="1050" b="1" i="0">
                 <a:solidFill>
-                  <a:srgbClr val="FFFFFF"/>
+                  <a:srgbClr val="0F172A"/>
                 </a:solidFill>
               </a:rPr>
               <a:t>On Budget</a:t>
@@ -15621,7 +15621,7 @@
             <a:r>
               <a:rPr sz="900" b="0" i="0">
                 <a:solidFill>
-                  <a:srgbClr val="8F96B3"/>
+                  <a:srgbClr val="4A5A82"/>
                 </a:solidFill>
               </a:rPr>
               <a:t>Actual spend of $1.45M is tracking below forecast. Remaining balance of $1.55M provides healthy fiscal buffer.</a:t>
@@ -15644,11 +15644,11 @@
             <a:avLst/>
           </a:prstGeom>
           <a:solidFill>
-            <a:srgbClr val="1A1D27"/>
+            <a:srgbClr val="FFFFFF"/>
           </a:solidFill>
           <a:ln w="9525">
             <a:solidFill>
-              <a:srgbClr val="2E3350"/>
+              <a:srgbClr val="C4D2EB"/>
             </a:solidFill>
           </a:ln>
         </p:spPr>
@@ -15689,7 +15689,7 @@
             <a:avLst/>
           </a:prstGeom>
           <a:solidFill>
-            <a:srgbClr val="22C55E"/>
+            <a:srgbClr val="16803D"/>
           </a:solidFill>
           <a:ln>
             <a:noFill/>
@@ -15743,7 +15743,7 @@
             <a:r>
               <a:rPr sz="1050" b="1" i="0">
                 <a:solidFill>
-                  <a:srgbClr val="FFFFFF"/>
+                  <a:srgbClr val="0F172A"/>
                 </a:solidFill>
               </a:rPr>
               <a:t>Delivery On Track</a:t>
@@ -15777,7 +15777,7 @@
             <a:r>
               <a:rPr sz="900" b="0" i="0">
                 <a:solidFill>
-                  <a:srgbClr val="8F96B3"/>
+                  <a:srgbClr val="4A5A82"/>
                 </a:solidFill>
               </a:rPr>
               <a:t>Sprint 1 completed. Sprint 2 in progress. Core MVP capabilities on schedule for Groups 3–9.</a:t>
@@ -15800,11 +15800,11 @@
             <a:avLst/>
           </a:prstGeom>
           <a:solidFill>
-            <a:srgbClr val="1A1D27"/>
+            <a:srgbClr val="FFFFFF"/>
           </a:solidFill>
           <a:ln w="9525">
             <a:solidFill>
-              <a:srgbClr val="2E3350"/>
+              <a:srgbClr val="C4D2EB"/>
             </a:solidFill>
           </a:ln>
         </p:spPr>
@@ -15845,7 +15845,7 @@
             <a:avLst/>
           </a:prstGeom>
           <a:solidFill>
-            <a:srgbClr val="EF4444"/>
+            <a:srgbClr val="DC2626"/>
           </a:solidFill>
           <a:ln>
             <a:noFill/>
@@ -15899,7 +15899,7 @@
             <a:r>
               <a:rPr sz="1050" b="1" i="0">
                 <a:solidFill>
-                  <a:srgbClr val="FFFFFF"/>
+                  <a:srgbClr val="0F172A"/>
                 </a:solidFill>
               </a:rPr>
               <a:t>Quality Attention Needed</a:t>
@@ -15933,7 +15933,7 @@
             <a:r>
               <a:rPr sz="900" b="0" i="0">
                 <a:solidFill>
-                  <a:srgbClr val="8F96B3"/>
+                  <a:srgbClr val="4A5A82"/>
                 </a:solidFill>
               </a:rPr>
               <a:t>Build/environment issues were encountered in Sprint 1. Tech Lead hiring in progress to prevent recurrence.</a:t>
@@ -15956,11 +15956,11 @@
             <a:avLst/>
           </a:prstGeom>
           <a:solidFill>
-            <a:srgbClr val="1A1D27"/>
+            <a:srgbClr val="FFFFFF"/>
           </a:solidFill>
           <a:ln w="9525">
             <a:solidFill>
-              <a:srgbClr val="2E3350"/>
+              <a:srgbClr val="C4D2EB"/>
             </a:solidFill>
           </a:ln>
         </p:spPr>
@@ -16001,7 +16001,7 @@
             <a:avLst/>
           </a:prstGeom>
           <a:solidFill>
-            <a:srgbClr val="F59E0B"/>
+            <a:srgbClr val="D97706"/>
           </a:solidFill>
           <a:ln>
             <a:noFill/>
@@ -16055,7 +16055,7 @@
             <a:r>
               <a:rPr sz="1050" b="1" i="0">
                 <a:solidFill>
-                  <a:srgbClr val="FFFFFF"/>
+                  <a:srgbClr val="0F172A"/>
                 </a:solidFill>
               </a:rPr>
               <a:t>Decisions Pending</a:t>
@@ -16089,7 +16089,7 @@
             <a:r>
               <a:rPr sz="900" b="0" i="0">
                 <a:solidFill>
-                  <a:srgbClr val="8F96B3"/>
+                  <a:srgbClr val="4A5A82"/>
                 </a:solidFill>
               </a:rPr>
               <a:t>Workflow finalization and registration number automation require program decisions to maintain velocity.</a:t>
@@ -16123,7 +16123,7 @@
             <a:r>
               <a:rPr sz="750" b="1" i="0">
                 <a:solidFill>
-                  <a:srgbClr val="8F96B3"/>
+                  <a:srgbClr val="4A5A82"/>
                 </a:solidFill>
               </a:rPr>
               <a:t>IMMEDIATE NEXT STEPS</a:t>
@@ -16146,11 +16146,11 @@
             <a:avLst/>
           </a:prstGeom>
           <a:solidFill>
-            <a:srgbClr val="22263A"/>
+            <a:srgbClr val="E5EEFC"/>
           </a:solidFill>
           <a:ln w="9525">
             <a:solidFill>
-              <a:srgbClr val="2E3350"/>
+              <a:srgbClr val="C4D2EB"/>
             </a:solidFill>
           </a:ln>
         </p:spPr>
@@ -16191,7 +16191,7 @@
             <a:avLst/>
           </a:prstGeom>
           <a:solidFill>
-            <a:srgbClr val="4F8EF7"/>
+            <a:srgbClr val="2563EB"/>
           </a:solidFill>
           <a:ln>
             <a:noFill/>
@@ -16245,7 +16245,7 @@
             <a:r>
               <a:rPr sz="950" b="1" i="0">
                 <a:solidFill>
-                  <a:srgbClr val="FFFFFF"/>
+                  <a:srgbClr val="0F172A"/>
                 </a:solidFill>
               </a:rPr>
               <a:t>Complete Sprint 2</a:t>
@@ -16279,7 +16279,7 @@
             <a:r>
               <a:rPr sz="900" b="0" i="0">
                 <a:solidFill>
-                  <a:srgbClr val="4F8EF7"/>
+                  <a:srgbClr val="2563EB"/>
                 </a:solidFill>
               </a:rPr>
               <a:t>Jul 1–14, 2026</a:t>
@@ -16313,7 +16313,7 @@
             <a:r>
               <a:rPr sz="900" b="0" i="0">
                 <a:solidFill>
-                  <a:srgbClr val="8F96B3"/>
+                  <a:srgbClr val="4A5A82"/>
                 </a:solidFill>
               </a:rPr>
               <a:t>Enable customer notifications &amp; RHP Team inbox</a:t>
@@ -16336,11 +16336,11 @@
             <a:avLst/>
           </a:prstGeom>
           <a:solidFill>
-            <a:srgbClr val="1A1D27"/>
+            <a:srgbClr val="FFFFFF"/>
           </a:solidFill>
           <a:ln w="9525">
             <a:solidFill>
-              <a:srgbClr val="2E3350"/>
+              <a:srgbClr val="C4D2EB"/>
             </a:solidFill>
           </a:ln>
         </p:spPr>
@@ -16381,7 +16381,7 @@
             <a:avLst/>
           </a:prstGeom>
           <a:solidFill>
-            <a:srgbClr val="4F8EF7"/>
+            <a:srgbClr val="2563EB"/>
           </a:solidFill>
           <a:ln>
             <a:noFill/>
@@ -16435,7 +16435,7 @@
             <a:r>
               <a:rPr sz="950" b="1" i="0">
                 <a:solidFill>
-                  <a:srgbClr val="FFFFFF"/>
+                  <a:srgbClr val="0F172A"/>
                 </a:solidFill>
               </a:rPr>
               <a:t>Finalize Workflow</a:t>
@@ -16469,7 +16469,7 @@
             <a:r>
               <a:rPr sz="900" b="0" i="0">
                 <a:solidFill>
-                  <a:srgbClr val="4F8EF7"/>
+                  <a:srgbClr val="2563EB"/>
                 </a:solidFill>
               </a:rPr>
               <a:t>Ongoing</a:t>
@@ -16503,7 +16503,7 @@
             <a:r>
               <a:rPr sz="900" b="0" i="0">
                 <a:solidFill>
-                  <a:srgbClr val="8F96B3"/>
+                  <a:srgbClr val="4A5A82"/>
                 </a:solidFill>
               </a:rPr>
               <a:t>Resolve non-ETS workflow with DoIT &amp; MDE teams</a:t>
@@ -16526,11 +16526,11 @@
             <a:avLst/>
           </a:prstGeom>
           <a:solidFill>
-            <a:srgbClr val="22263A"/>
+            <a:srgbClr val="E5EEFC"/>
           </a:solidFill>
           <a:ln w="9525">
             <a:solidFill>
-              <a:srgbClr val="2E3350"/>
+              <a:srgbClr val="C4D2EB"/>
             </a:solidFill>
           </a:ln>
         </p:spPr>
@@ -16571,7 +16571,7 @@
             <a:avLst/>
           </a:prstGeom>
           <a:solidFill>
-            <a:srgbClr val="F59E0B"/>
+            <a:srgbClr val="D97706"/>
           </a:solidFill>
           <a:ln>
             <a:noFill/>
@@ -16625,7 +16625,7 @@
             <a:r>
               <a:rPr sz="950" b="1" i="0">
                 <a:solidFill>
-                  <a:srgbClr val="FFFFFF"/>
+                  <a:srgbClr val="0F172A"/>
                 </a:solidFill>
               </a:rPr>
               <a:t>State Data Officer Input</a:t>
@@ -16659,7 +16659,7 @@
             <a:r>
               <a:rPr sz="900" b="0" i="0">
                 <a:solidFill>
-                  <a:srgbClr val="F59E0B"/>
+                  <a:srgbClr val="D97706"/>
                 </a:solidFill>
               </a:rPr>
               <a:t>Awaiting</a:t>
@@ -16693,7 +16693,7 @@
             <a:r>
               <a:rPr sz="900" b="0" i="0">
                 <a:solidFill>
-                  <a:srgbClr val="8F96B3"/>
+                  <a:srgbClr val="4A5A82"/>
                 </a:solidFill>
               </a:rPr>
               <a:t>Liability Check decision needed from Emil/Paul/DoIT</a:t>
@@ -16716,11 +16716,11 @@
             <a:avLst/>
           </a:prstGeom>
           <a:solidFill>
-            <a:srgbClr val="1A1D27"/>
+            <a:srgbClr val="FFFFFF"/>
           </a:solidFill>
           <a:ln w="9525">
             <a:solidFill>
-              <a:srgbClr val="2E3350"/>
+              <a:srgbClr val="C4D2EB"/>
             </a:solidFill>
           </a:ln>
         </p:spPr>
@@ -16761,7 +16761,7 @@
             <a:avLst/>
           </a:prstGeom>
           <a:solidFill>
-            <a:srgbClr val="22C55E"/>
+            <a:srgbClr val="16803D"/>
           </a:solidFill>
           <a:ln>
             <a:noFill/>
@@ -16815,7 +16815,7 @@
             <a:r>
               <a:rPr sz="950" b="1" i="0">
                 <a:solidFill>
-                  <a:srgbClr val="FFFFFF"/>
+                  <a:srgbClr val="0F172A"/>
                 </a:solidFill>
               </a:rPr>
               <a:t>Hire Tech Lead</a:t>
@@ -16849,7 +16849,7 @@
             <a:r>
               <a:rPr sz="900" b="0" i="0">
                 <a:solidFill>
-                  <a:srgbClr val="22C55E"/>
+                  <a:srgbClr val="16803D"/>
                 </a:solidFill>
               </a:rPr>
               <a:t>Active Recruiting</a:t>
@@ -16883,7 +16883,7 @@
             <a:r>
               <a:rPr sz="900" b="0" i="0">
                 <a:solidFill>
-                  <a:srgbClr val="8F96B3"/>
+                  <a:srgbClr val="4A5A82"/>
                 </a:solidFill>
               </a:rPr>
               <a:t>Address build/environment blockers proactively</a:t>
@@ -16906,11 +16906,11 @@
             <a:avLst/>
           </a:prstGeom>
           <a:solidFill>
-            <a:srgbClr val="22263A"/>
+            <a:srgbClr val="E5EEFC"/>
           </a:solidFill>
           <a:ln w="9525">
             <a:solidFill>
-              <a:srgbClr val="2E3350"/>
+              <a:srgbClr val="C4D2EB"/>
             </a:solidFill>
           </a:ln>
         </p:spPr>
@@ -16951,7 +16951,7 @@
             <a:avLst/>
           </a:prstGeom>
           <a:solidFill>
-            <a:srgbClr val="22C55E"/>
+            <a:srgbClr val="16803D"/>
           </a:solidFill>
           <a:ln>
             <a:noFill/>
@@ -17005,7 +17005,7 @@
             <a:r>
               <a:rPr sz="950" b="1" i="0">
                 <a:solidFill>
-                  <a:srgbClr val="FFFFFF"/>
+                  <a:srgbClr val="0F172A"/>
                 </a:solidFill>
               </a:rPr>
               <a:t>User Testing Alignment</a:t>
@@ -17039,7 +17039,7 @@
             <a:r>
               <a:rPr sz="900" b="0" i="0">
                 <a:solidFill>
-                  <a:srgbClr val="22C55E"/>
+                  <a:srgbClr val="16803D"/>
                 </a:solidFill>
               </a:rPr>
               <a:t>Sprint 2–3</a:t>
@@ -17073,7 +17073,7 @@
             <a:r>
               <a:rPr sz="900" b="0" i="0">
                 <a:solidFill>
-                  <a:srgbClr val="8F96B3"/>
+                  <a:srgbClr val="4A5A82"/>
                 </a:solidFill>
               </a:rPr>
               <a:t>Coordinate with Paul to integrate testing into dev cycle</a:t>
@@ -17097,7 +17097,7 @@
           </a:prstGeom>
           <a:ln w="6350">
             <a:solidFill>
-              <a:srgbClr val="2E3350"/>
+              <a:srgbClr val="C4D2EB"/>
             </a:solidFill>
           </a:ln>
         </p:spPr>
@@ -17142,7 +17142,7 @@
             <a:r>
               <a:rPr sz="800" b="0" i="0">
                 <a:solidFill>
-                  <a:srgbClr val="8F96B3"/>
+                  <a:srgbClr val="4A5A82"/>
                 </a:solidFill>
               </a:rPr>
               <a:t>RHP Modernization Initiative  ·  MDE  ·  Prepared for Executive Review  ·  July 10, 2026</a:t>

</xml_diff>